<commit_message>
colab compatibility first day
</commit_message>
<xml_diff>
--- a/nlp_explainabilty/NLP_tutorial.pptx
+++ b/nlp_explainabilty/NLP_tutorial.pptx
@@ -19,7 +19,7 @@
     <p:sldId id="260" r:id="rId10"/>
     <p:sldId id="261" r:id="rId11"/>
     <p:sldId id="290" r:id="rId12"/>
-    <p:sldId id="291" r:id="rId13"/>
+    <p:sldId id="292" r:id="rId13"/>
   </p:sldIdLst>
   <p:sldSz cx="24382413" cy="13716000"/>
   <p:notesSz cx="6858000" cy="9144000"/>
@@ -786,7 +786,7 @@
           <a:p>
             <a:fld id="{31A4E5E5-E8A1-43D3-A7D1-CA55F205380F}" type="datetimeFigureOut">
               <a:rPr lang="hu-HU" smtClean="0"/>
-              <a:t>2026. 07. 07.</a:t>
+              <a:t>2026. 07. 08.</a:t>
             </a:fld>
             <a:endParaRPr lang="hu-HU"/>
           </a:p>
@@ -967,7 +967,7 @@
           <a:p>
             <a:fld id="{CDCCA316-0123-4387-8862-50A9C2E11E45}" type="datetimeFigureOut">
               <a:rPr lang="hu-HU" smtClean="0"/>
-              <a:t>2026. 07. 07.</a:t>
+              <a:t>2026. 07. 08.</a:t>
             </a:fld>
             <a:endParaRPr lang="hu-HU"/>
           </a:p>
@@ -1742,6 +1742,114 @@
 </p:notes>
 </file>
 
+<file path=ppt/notesSlides/notesSlide7.xml><?xml version="1.0" encoding="utf-8"?>
+<p:notes xmlns:a="http://schemas.openxmlformats.org/drawingml/2006/main" xmlns:r="http://schemas.openxmlformats.org/officeDocument/2006/relationships" xmlns:p="http://schemas.openxmlformats.org/presentationml/2006/main">
+  <p:cSld>
+    <p:spTree>
+      <p:nvGrpSpPr>
+        <p:cNvPr id="1" name="">
+          <a:extLst>
+            <a:ext uri="{FF2B5EF4-FFF2-40B4-BE49-F238E27FC236}">
+              <a16:creationId xmlns:a16="http://schemas.microsoft.com/office/drawing/2014/main" id="{C3B534C3-4540-4AE5-95C4-70DB4B588AD9}"/>
+            </a:ext>
+          </a:extLst>
+        </p:cNvPr>
+        <p:cNvGrpSpPr/>
+        <p:nvPr/>
+      </p:nvGrpSpPr>
+      <p:grpSpPr>
+        <a:xfrm>
+          <a:off x="0" y="0"/>
+          <a:ext cx="0" cy="0"/>
+          <a:chOff x="0" y="0"/>
+          <a:chExt cx="0" cy="0"/>
+        </a:xfrm>
+      </p:grpSpPr>
+      <p:sp>
+        <p:nvSpPr>
+          <p:cNvPr id="2" name="Slide Image Placeholder 1">
+            <a:extLst>
+              <a:ext uri="{FF2B5EF4-FFF2-40B4-BE49-F238E27FC236}">
+                <a16:creationId xmlns:a16="http://schemas.microsoft.com/office/drawing/2014/main" id="{73EF661B-A7E6-F26E-BC61-198DD34466D5}"/>
+              </a:ext>
+            </a:extLst>
+          </p:cNvPr>
+          <p:cNvSpPr>
+            <a:spLocks noGrp="1" noRot="1" noChangeAspect="1"/>
+          </p:cNvSpPr>
+          <p:nvPr>
+            <p:ph type="sldImg"/>
+          </p:nvPr>
+        </p:nvSpPr>
+        <p:spPr/>
+      </p:sp>
+      <p:sp>
+        <p:nvSpPr>
+          <p:cNvPr id="3" name="Notes Placeholder 2">
+            <a:extLst>
+              <a:ext uri="{FF2B5EF4-FFF2-40B4-BE49-F238E27FC236}">
+                <a16:creationId xmlns:a16="http://schemas.microsoft.com/office/drawing/2014/main" id="{D2B1B5C4-3E74-8BB8-EF2B-423AFD06B2B8}"/>
+              </a:ext>
+            </a:extLst>
+          </p:cNvPr>
+          <p:cNvSpPr>
+            <a:spLocks noGrp="1"/>
+          </p:cNvSpPr>
+          <p:nvPr>
+            <p:ph type="body" idx="1"/>
+          </p:nvPr>
+        </p:nvSpPr>
+        <p:spPr/>
+        <p:txBody>
+          <a:bodyPr/>
+          <a:lstStyle/>
+          <a:p>
+            <a:endParaRPr lang="en-US" dirty="0"/>
+          </a:p>
+        </p:txBody>
+      </p:sp>
+      <p:sp>
+        <p:nvSpPr>
+          <p:cNvPr id="4" name="Slide Number Placeholder 3">
+            <a:extLst>
+              <a:ext uri="{FF2B5EF4-FFF2-40B4-BE49-F238E27FC236}">
+                <a16:creationId xmlns:a16="http://schemas.microsoft.com/office/drawing/2014/main" id="{90217948-869F-AD85-97C0-1BBEF3654514}"/>
+              </a:ext>
+            </a:extLst>
+          </p:cNvPr>
+          <p:cNvSpPr>
+            <a:spLocks noGrp="1"/>
+          </p:cNvSpPr>
+          <p:nvPr>
+            <p:ph type="sldNum" sz="quarter" idx="10"/>
+          </p:nvPr>
+        </p:nvSpPr>
+        <p:spPr/>
+        <p:txBody>
+          <a:bodyPr/>
+          <a:lstStyle/>
+          <a:p>
+            <a:fld id="{F7021451-1387-4CA6-816F-3879F97B5CBC}" type="slidenum">
+              <a:rPr lang="en-US"/>
+              <a:t>8</a:t>
+            </a:fld>
+            <a:endParaRPr lang="en-US"/>
+          </a:p>
+        </p:txBody>
+      </p:sp>
+    </p:spTree>
+    <p:extLst>
+      <p:ext uri="{BB962C8B-B14F-4D97-AF65-F5344CB8AC3E}">
+        <p14:creationId xmlns:p14="http://schemas.microsoft.com/office/powerpoint/2010/main" val="1252430372"/>
+      </p:ext>
+    </p:extLst>
+  </p:cSld>
+  <p:clrMapOvr>
+    <a:masterClrMapping/>
+  </p:clrMapOvr>
+</p:notes>
+</file>
+
 <file path=ppt/slideLayouts/slideLayout1.xml><?xml version="1.0" encoding="utf-8"?>
 <p:sldLayout xmlns:a="http://schemas.openxmlformats.org/drawingml/2006/main" xmlns:r="http://schemas.openxmlformats.org/officeDocument/2006/relationships" xmlns:p="http://schemas.openxmlformats.org/presentationml/2006/main" preserve="1" userDrawn="1">
   <p:cSld name="Nyitókép">
@@ -5185,7 +5293,7 @@
           <a:p>
             <a:fld id="{5FBA2458-2494-4835-90F3-2C2A6F3DCAEC}" type="datetimeFigureOut">
               <a:rPr lang="hu-HU" smtClean="0"/>
-              <a:t>2026. 07. 07.</a:t>
+              <a:t>2026. 07. 08.</a:t>
             </a:fld>
             <a:endParaRPr lang="hu-HU" dirty="0"/>
           </a:p>
@@ -5843,7 +5951,7 @@
           <a:p>
             <a:fld id="{5FBA2458-2494-4835-90F3-2C2A6F3DCAEC}" type="datetimeFigureOut">
               <a:rPr lang="hu-HU" smtClean="0"/>
-              <a:t>2026. 07. 07.</a:t>
+              <a:t>2026. 07. 08.</a:t>
             </a:fld>
             <a:endParaRPr lang="hu-HU" dirty="0"/>
           </a:p>
@@ -8009,6 +8117,590 @@
   <p:clrMapOvr>
     <a:masterClrMapping/>
   </p:clrMapOvr>
+  <p:timing>
+    <p:tnLst>
+      <p:par>
+        <p:cTn id="1" dur="indefinite" restart="never" nodeType="tmRoot">
+          <p:childTnLst>
+            <p:seq concurrent="1" nextAc="seek">
+              <p:cTn id="2" dur="indefinite" nodeType="mainSeq">
+                <p:childTnLst>
+                  <p:par>
+                    <p:cTn id="3" fill="hold">
+                      <p:stCondLst>
+                        <p:cond delay="indefinite"/>
+                      </p:stCondLst>
+                      <p:childTnLst>
+                        <p:par>
+                          <p:cTn id="4" fill="hold">
+                            <p:stCondLst>
+                              <p:cond delay="0"/>
+                            </p:stCondLst>
+                            <p:childTnLst>
+                              <p:par>
+                                <p:cTn id="5" presetID="10" presetClass="entr" presetSubtype="0" fill="hold" grpId="0" nodeType="clickEffect">
+                                  <p:stCondLst>
+                                    <p:cond delay="0"/>
+                                  </p:stCondLst>
+                                  <p:childTnLst>
+                                    <p:set>
+                                      <p:cBhvr>
+                                        <p:cTn id="6" dur="1" fill="hold">
+                                          <p:stCondLst>
+                                            <p:cond delay="0"/>
+                                          </p:stCondLst>
+                                        </p:cTn>
+                                        <p:tgtEl>
+                                          <p:spTgt spid="4"/>
+                                        </p:tgtEl>
+                                        <p:attrNameLst>
+                                          <p:attrName>style.visibility</p:attrName>
+                                        </p:attrNameLst>
+                                      </p:cBhvr>
+                                      <p:to>
+                                        <p:strVal val="visible"/>
+                                      </p:to>
+                                    </p:set>
+                                    <p:animEffect transition="in" filter="fade">
+                                      <p:cBhvr>
+                                        <p:cTn id="7" dur="500"/>
+                                        <p:tgtEl>
+                                          <p:spTgt spid="4"/>
+                                        </p:tgtEl>
+                                      </p:cBhvr>
+                                    </p:animEffect>
+                                  </p:childTnLst>
+                                </p:cTn>
+                              </p:par>
+                              <p:par>
+                                <p:cTn id="8" presetID="10" presetClass="entr" presetSubtype="0" fill="hold" grpId="0" nodeType="withEffect">
+                                  <p:stCondLst>
+                                    <p:cond delay="0"/>
+                                  </p:stCondLst>
+                                  <p:childTnLst>
+                                    <p:set>
+                                      <p:cBhvr>
+                                        <p:cTn id="9" dur="1" fill="hold">
+                                          <p:stCondLst>
+                                            <p:cond delay="0"/>
+                                          </p:stCondLst>
+                                        </p:cTn>
+                                        <p:tgtEl>
+                                          <p:spTgt spid="5"/>
+                                        </p:tgtEl>
+                                        <p:attrNameLst>
+                                          <p:attrName>style.visibility</p:attrName>
+                                        </p:attrNameLst>
+                                      </p:cBhvr>
+                                      <p:to>
+                                        <p:strVal val="visible"/>
+                                      </p:to>
+                                    </p:set>
+                                    <p:animEffect transition="in" filter="fade">
+                                      <p:cBhvr>
+                                        <p:cTn id="10" dur="500"/>
+                                        <p:tgtEl>
+                                          <p:spTgt spid="5"/>
+                                        </p:tgtEl>
+                                      </p:cBhvr>
+                                    </p:animEffect>
+                                  </p:childTnLst>
+                                </p:cTn>
+                              </p:par>
+                              <p:par>
+                                <p:cTn id="11" presetID="10" presetClass="entr" presetSubtype="0" fill="hold" grpId="0" nodeType="withEffect">
+                                  <p:stCondLst>
+                                    <p:cond delay="0"/>
+                                  </p:stCondLst>
+                                  <p:childTnLst>
+                                    <p:set>
+                                      <p:cBhvr>
+                                        <p:cTn id="12" dur="1" fill="hold">
+                                          <p:stCondLst>
+                                            <p:cond delay="0"/>
+                                          </p:stCondLst>
+                                        </p:cTn>
+                                        <p:tgtEl>
+                                          <p:spTgt spid="6"/>
+                                        </p:tgtEl>
+                                        <p:attrNameLst>
+                                          <p:attrName>style.visibility</p:attrName>
+                                        </p:attrNameLst>
+                                      </p:cBhvr>
+                                      <p:to>
+                                        <p:strVal val="visible"/>
+                                      </p:to>
+                                    </p:set>
+                                    <p:animEffect transition="in" filter="fade">
+                                      <p:cBhvr>
+                                        <p:cTn id="13" dur="500"/>
+                                        <p:tgtEl>
+                                          <p:spTgt spid="6"/>
+                                        </p:tgtEl>
+                                      </p:cBhvr>
+                                    </p:animEffect>
+                                  </p:childTnLst>
+                                </p:cTn>
+                              </p:par>
+                              <p:par>
+                                <p:cTn id="14" presetID="10" presetClass="entr" presetSubtype="0" fill="hold" nodeType="withEffect">
+                                  <p:stCondLst>
+                                    <p:cond delay="0"/>
+                                  </p:stCondLst>
+                                  <p:childTnLst>
+                                    <p:set>
+                                      <p:cBhvr>
+                                        <p:cTn id="15" dur="1" fill="hold">
+                                          <p:stCondLst>
+                                            <p:cond delay="0"/>
+                                          </p:stCondLst>
+                                        </p:cTn>
+                                        <p:tgtEl>
+                                          <p:spTgt spid="35"/>
+                                        </p:tgtEl>
+                                        <p:attrNameLst>
+                                          <p:attrName>style.visibility</p:attrName>
+                                        </p:attrNameLst>
+                                      </p:cBhvr>
+                                      <p:to>
+                                        <p:strVal val="visible"/>
+                                      </p:to>
+                                    </p:set>
+                                    <p:animEffect transition="in" filter="fade">
+                                      <p:cBhvr>
+                                        <p:cTn id="16" dur="500"/>
+                                        <p:tgtEl>
+                                          <p:spTgt spid="35"/>
+                                        </p:tgtEl>
+                                      </p:cBhvr>
+                                    </p:animEffect>
+                                  </p:childTnLst>
+                                </p:cTn>
+                              </p:par>
+                              <p:par>
+                                <p:cTn id="17" presetID="10" presetClass="entr" presetSubtype="0" fill="hold" grpId="0" nodeType="withEffect">
+                                  <p:stCondLst>
+                                    <p:cond delay="0"/>
+                                  </p:stCondLst>
+                                  <p:childTnLst>
+                                    <p:set>
+                                      <p:cBhvr>
+                                        <p:cTn id="18" dur="1" fill="hold">
+                                          <p:stCondLst>
+                                            <p:cond delay="0"/>
+                                          </p:stCondLst>
+                                        </p:cTn>
+                                        <p:tgtEl>
+                                          <p:spTgt spid="9"/>
+                                        </p:tgtEl>
+                                        <p:attrNameLst>
+                                          <p:attrName>style.visibility</p:attrName>
+                                        </p:attrNameLst>
+                                      </p:cBhvr>
+                                      <p:to>
+                                        <p:strVal val="visible"/>
+                                      </p:to>
+                                    </p:set>
+                                    <p:animEffect transition="in" filter="fade">
+                                      <p:cBhvr>
+                                        <p:cTn id="19" dur="500"/>
+                                        <p:tgtEl>
+                                          <p:spTgt spid="9"/>
+                                        </p:tgtEl>
+                                      </p:cBhvr>
+                                    </p:animEffect>
+                                  </p:childTnLst>
+                                </p:cTn>
+                              </p:par>
+                              <p:par>
+                                <p:cTn id="20" presetID="10" presetClass="entr" presetSubtype="0" fill="hold" grpId="0" nodeType="withEffect">
+                                  <p:stCondLst>
+                                    <p:cond delay="0"/>
+                                  </p:stCondLst>
+                                  <p:childTnLst>
+                                    <p:set>
+                                      <p:cBhvr>
+                                        <p:cTn id="21" dur="1" fill="hold">
+                                          <p:stCondLst>
+                                            <p:cond delay="0"/>
+                                          </p:stCondLst>
+                                        </p:cTn>
+                                        <p:tgtEl>
+                                          <p:spTgt spid="10"/>
+                                        </p:tgtEl>
+                                        <p:attrNameLst>
+                                          <p:attrName>style.visibility</p:attrName>
+                                        </p:attrNameLst>
+                                      </p:cBhvr>
+                                      <p:to>
+                                        <p:strVal val="visible"/>
+                                      </p:to>
+                                    </p:set>
+                                    <p:animEffect transition="in" filter="fade">
+                                      <p:cBhvr>
+                                        <p:cTn id="22" dur="500"/>
+                                        <p:tgtEl>
+                                          <p:spTgt spid="10"/>
+                                        </p:tgtEl>
+                                      </p:cBhvr>
+                                    </p:animEffect>
+                                  </p:childTnLst>
+                                </p:cTn>
+                              </p:par>
+                              <p:par>
+                                <p:cTn id="23" presetID="10" presetClass="entr" presetSubtype="0" fill="hold" grpId="0" nodeType="withEffect">
+                                  <p:stCondLst>
+                                    <p:cond delay="0"/>
+                                  </p:stCondLst>
+                                  <p:childTnLst>
+                                    <p:set>
+                                      <p:cBhvr>
+                                        <p:cTn id="24" dur="1" fill="hold">
+                                          <p:stCondLst>
+                                            <p:cond delay="0"/>
+                                          </p:stCondLst>
+                                        </p:cTn>
+                                        <p:tgtEl>
+                                          <p:spTgt spid="11"/>
+                                        </p:tgtEl>
+                                        <p:attrNameLst>
+                                          <p:attrName>style.visibility</p:attrName>
+                                        </p:attrNameLst>
+                                      </p:cBhvr>
+                                      <p:to>
+                                        <p:strVal val="visible"/>
+                                      </p:to>
+                                    </p:set>
+                                    <p:animEffect transition="in" filter="fade">
+                                      <p:cBhvr>
+                                        <p:cTn id="25" dur="500"/>
+                                        <p:tgtEl>
+                                          <p:spTgt spid="11"/>
+                                        </p:tgtEl>
+                                      </p:cBhvr>
+                                    </p:animEffect>
+                                  </p:childTnLst>
+                                </p:cTn>
+                              </p:par>
+                              <p:par>
+                                <p:cTn id="26" presetID="10" presetClass="entr" presetSubtype="0" fill="hold" nodeType="withEffect">
+                                  <p:stCondLst>
+                                    <p:cond delay="0"/>
+                                  </p:stCondLst>
+                                  <p:childTnLst>
+                                    <p:set>
+                                      <p:cBhvr>
+                                        <p:cTn id="27" dur="1" fill="hold">
+                                          <p:stCondLst>
+                                            <p:cond delay="0"/>
+                                          </p:stCondLst>
+                                        </p:cTn>
+                                        <p:tgtEl>
+                                          <p:spTgt spid="36"/>
+                                        </p:tgtEl>
+                                        <p:attrNameLst>
+                                          <p:attrName>style.visibility</p:attrName>
+                                        </p:attrNameLst>
+                                      </p:cBhvr>
+                                      <p:to>
+                                        <p:strVal val="visible"/>
+                                      </p:to>
+                                    </p:set>
+                                    <p:animEffect transition="in" filter="fade">
+                                      <p:cBhvr>
+                                        <p:cTn id="28" dur="500"/>
+                                        <p:tgtEl>
+                                          <p:spTgt spid="36"/>
+                                        </p:tgtEl>
+                                      </p:cBhvr>
+                                    </p:animEffect>
+                                  </p:childTnLst>
+                                </p:cTn>
+                              </p:par>
+                              <p:par>
+                                <p:cTn id="29" presetID="10" presetClass="entr" presetSubtype="0" fill="hold" grpId="0" nodeType="withEffect">
+                                  <p:stCondLst>
+                                    <p:cond delay="0"/>
+                                  </p:stCondLst>
+                                  <p:childTnLst>
+                                    <p:set>
+                                      <p:cBhvr>
+                                        <p:cTn id="30" dur="1" fill="hold">
+                                          <p:stCondLst>
+                                            <p:cond delay="0"/>
+                                          </p:stCondLst>
+                                        </p:cTn>
+                                        <p:tgtEl>
+                                          <p:spTgt spid="14"/>
+                                        </p:tgtEl>
+                                        <p:attrNameLst>
+                                          <p:attrName>style.visibility</p:attrName>
+                                        </p:attrNameLst>
+                                      </p:cBhvr>
+                                      <p:to>
+                                        <p:strVal val="visible"/>
+                                      </p:to>
+                                    </p:set>
+                                    <p:animEffect transition="in" filter="fade">
+                                      <p:cBhvr>
+                                        <p:cTn id="31" dur="500"/>
+                                        <p:tgtEl>
+                                          <p:spTgt spid="14"/>
+                                        </p:tgtEl>
+                                      </p:cBhvr>
+                                    </p:animEffect>
+                                  </p:childTnLst>
+                                </p:cTn>
+                              </p:par>
+                              <p:par>
+                                <p:cTn id="32" presetID="10" presetClass="entr" presetSubtype="0" fill="hold" grpId="0" nodeType="withEffect">
+                                  <p:stCondLst>
+                                    <p:cond delay="0"/>
+                                  </p:stCondLst>
+                                  <p:childTnLst>
+                                    <p:set>
+                                      <p:cBhvr>
+                                        <p:cTn id="33" dur="1" fill="hold">
+                                          <p:stCondLst>
+                                            <p:cond delay="0"/>
+                                          </p:stCondLst>
+                                        </p:cTn>
+                                        <p:tgtEl>
+                                          <p:spTgt spid="15"/>
+                                        </p:tgtEl>
+                                        <p:attrNameLst>
+                                          <p:attrName>style.visibility</p:attrName>
+                                        </p:attrNameLst>
+                                      </p:cBhvr>
+                                      <p:to>
+                                        <p:strVal val="visible"/>
+                                      </p:to>
+                                    </p:set>
+                                    <p:animEffect transition="in" filter="fade">
+                                      <p:cBhvr>
+                                        <p:cTn id="34" dur="500"/>
+                                        <p:tgtEl>
+                                          <p:spTgt spid="15"/>
+                                        </p:tgtEl>
+                                      </p:cBhvr>
+                                    </p:animEffect>
+                                  </p:childTnLst>
+                                </p:cTn>
+                              </p:par>
+                              <p:par>
+                                <p:cTn id="35" presetID="10" presetClass="entr" presetSubtype="0" fill="hold" grpId="0" nodeType="withEffect">
+                                  <p:stCondLst>
+                                    <p:cond delay="0"/>
+                                  </p:stCondLst>
+                                  <p:childTnLst>
+                                    <p:set>
+                                      <p:cBhvr>
+                                        <p:cTn id="36" dur="1" fill="hold">
+                                          <p:stCondLst>
+                                            <p:cond delay="0"/>
+                                          </p:stCondLst>
+                                        </p:cTn>
+                                        <p:tgtEl>
+                                          <p:spTgt spid="16"/>
+                                        </p:tgtEl>
+                                        <p:attrNameLst>
+                                          <p:attrName>style.visibility</p:attrName>
+                                        </p:attrNameLst>
+                                      </p:cBhvr>
+                                      <p:to>
+                                        <p:strVal val="visible"/>
+                                      </p:to>
+                                    </p:set>
+                                    <p:animEffect transition="in" filter="fade">
+                                      <p:cBhvr>
+                                        <p:cTn id="37" dur="500"/>
+                                        <p:tgtEl>
+                                          <p:spTgt spid="16"/>
+                                        </p:tgtEl>
+                                      </p:cBhvr>
+                                    </p:animEffect>
+                                  </p:childTnLst>
+                                </p:cTn>
+                              </p:par>
+                              <p:par>
+                                <p:cTn id="38" presetID="10" presetClass="entr" presetSubtype="0" fill="hold" nodeType="withEffect">
+                                  <p:stCondLst>
+                                    <p:cond delay="0"/>
+                                  </p:stCondLst>
+                                  <p:childTnLst>
+                                    <p:set>
+                                      <p:cBhvr>
+                                        <p:cTn id="39" dur="1" fill="hold">
+                                          <p:stCondLst>
+                                            <p:cond delay="0"/>
+                                          </p:stCondLst>
+                                        </p:cTn>
+                                        <p:tgtEl>
+                                          <p:spTgt spid="37"/>
+                                        </p:tgtEl>
+                                        <p:attrNameLst>
+                                          <p:attrName>style.visibility</p:attrName>
+                                        </p:attrNameLst>
+                                      </p:cBhvr>
+                                      <p:to>
+                                        <p:strVal val="visible"/>
+                                      </p:to>
+                                    </p:set>
+                                    <p:animEffect transition="in" filter="fade">
+                                      <p:cBhvr>
+                                        <p:cTn id="40" dur="500"/>
+                                        <p:tgtEl>
+                                          <p:spTgt spid="37"/>
+                                        </p:tgtEl>
+                                      </p:cBhvr>
+                                    </p:animEffect>
+                                  </p:childTnLst>
+                                </p:cTn>
+                              </p:par>
+                              <p:par>
+                                <p:cTn id="41" presetID="10" presetClass="entr" presetSubtype="0" fill="hold" nodeType="withEffect">
+                                  <p:stCondLst>
+                                    <p:cond delay="0"/>
+                                  </p:stCondLst>
+                                  <p:childTnLst>
+                                    <p:set>
+                                      <p:cBhvr>
+                                        <p:cTn id="42" dur="1" fill="hold">
+                                          <p:stCondLst>
+                                            <p:cond delay="0"/>
+                                          </p:stCondLst>
+                                        </p:cTn>
+                                        <p:tgtEl>
+                                          <p:spTgt spid="40"/>
+                                        </p:tgtEl>
+                                        <p:attrNameLst>
+                                          <p:attrName>style.visibility</p:attrName>
+                                        </p:attrNameLst>
+                                      </p:cBhvr>
+                                      <p:to>
+                                        <p:strVal val="visible"/>
+                                      </p:to>
+                                    </p:set>
+                                    <p:animEffect transition="in" filter="fade">
+                                      <p:cBhvr>
+                                        <p:cTn id="43" dur="500"/>
+                                        <p:tgtEl>
+                                          <p:spTgt spid="40"/>
+                                        </p:tgtEl>
+                                      </p:cBhvr>
+                                    </p:animEffect>
+                                  </p:childTnLst>
+                                </p:cTn>
+                              </p:par>
+                              <p:par>
+                                <p:cTn id="44" presetID="10" presetClass="entr" presetSubtype="0" fill="hold" nodeType="withEffect">
+                                  <p:stCondLst>
+                                    <p:cond delay="0"/>
+                                  </p:stCondLst>
+                                  <p:childTnLst>
+                                    <p:set>
+                                      <p:cBhvr>
+                                        <p:cTn id="45" dur="1" fill="hold">
+                                          <p:stCondLst>
+                                            <p:cond delay="0"/>
+                                          </p:stCondLst>
+                                        </p:cTn>
+                                        <p:tgtEl>
+                                          <p:spTgt spid="39"/>
+                                        </p:tgtEl>
+                                        <p:attrNameLst>
+                                          <p:attrName>style.visibility</p:attrName>
+                                        </p:attrNameLst>
+                                      </p:cBhvr>
+                                      <p:to>
+                                        <p:strVal val="visible"/>
+                                      </p:to>
+                                    </p:set>
+                                    <p:animEffect transition="in" filter="fade">
+                                      <p:cBhvr>
+                                        <p:cTn id="46" dur="500"/>
+                                        <p:tgtEl>
+                                          <p:spTgt spid="39"/>
+                                        </p:tgtEl>
+                                      </p:cBhvr>
+                                    </p:animEffect>
+                                  </p:childTnLst>
+                                </p:cTn>
+                              </p:par>
+                              <p:par>
+                                <p:cTn id="47" presetID="10" presetClass="entr" presetSubtype="0" fill="hold" nodeType="withEffect">
+                                  <p:stCondLst>
+                                    <p:cond delay="0"/>
+                                  </p:stCondLst>
+                                  <p:childTnLst>
+                                    <p:set>
+                                      <p:cBhvr>
+                                        <p:cTn id="48" dur="1" fill="hold">
+                                          <p:stCondLst>
+                                            <p:cond delay="0"/>
+                                          </p:stCondLst>
+                                        </p:cTn>
+                                        <p:tgtEl>
+                                          <p:spTgt spid="38"/>
+                                        </p:tgtEl>
+                                        <p:attrNameLst>
+                                          <p:attrName>style.visibility</p:attrName>
+                                        </p:attrNameLst>
+                                      </p:cBhvr>
+                                      <p:to>
+                                        <p:strVal val="visible"/>
+                                      </p:to>
+                                    </p:set>
+                                    <p:animEffect transition="in" filter="fade">
+                                      <p:cBhvr>
+                                        <p:cTn id="49" dur="500"/>
+                                        <p:tgtEl>
+                                          <p:spTgt spid="38"/>
+                                        </p:tgtEl>
+                                      </p:cBhvr>
+                                    </p:animEffect>
+                                  </p:childTnLst>
+                                </p:cTn>
+                              </p:par>
+                            </p:childTnLst>
+                          </p:cTn>
+                        </p:par>
+                      </p:childTnLst>
+                    </p:cTn>
+                  </p:par>
+                </p:childTnLst>
+              </p:cTn>
+              <p:prevCondLst>
+                <p:cond evt="onPrev" delay="0">
+                  <p:tgtEl>
+                    <p:sldTgt/>
+                  </p:tgtEl>
+                </p:cond>
+              </p:prevCondLst>
+              <p:nextCondLst>
+                <p:cond evt="onNext" delay="0">
+                  <p:tgtEl>
+                    <p:sldTgt/>
+                  </p:tgtEl>
+                </p:cond>
+              </p:nextCondLst>
+            </p:seq>
+          </p:childTnLst>
+        </p:cTn>
+      </p:par>
+    </p:tnLst>
+    <p:bldLst>
+      <p:bldP spid="4" grpId="0" animBg="1"/>
+      <p:bldP spid="5" grpId="0" animBg="1"/>
+      <p:bldP spid="6" grpId="0" animBg="1"/>
+      <p:bldP spid="9" grpId="0" animBg="1"/>
+      <p:bldP spid="10" grpId="0" animBg="1"/>
+      <p:bldP spid="11" grpId="0" animBg="1"/>
+      <p:bldP spid="14" grpId="0" animBg="1"/>
+      <p:bldP spid="15" grpId="0" animBg="1"/>
+      <p:bldP spid="16" grpId="0" animBg="1"/>
+    </p:bldLst>
+  </p:timing>
 </p:sld>
 </file>
 
@@ -8546,7 +9238,7 @@
                   <a:srgbClr val="172C3A"/>
                 </a:solidFill>
               </a:rPr>
-              <a:t>how attention gives a first window into the model’s internal behavior</a:t>
+              <a:t>how can we look at the attention scores for explainability</a:t>
             </a:r>
             <a:endParaRPr lang="en-US" sz="4400" noProof="0" dirty="0"/>
           </a:p>
@@ -9819,6 +10511,614 @@
   <p:clrMapOvr>
     <a:masterClrMapping/>
   </p:clrMapOvr>
+  <p:timing>
+    <p:tnLst>
+      <p:par>
+        <p:cTn id="1" dur="indefinite" restart="never" nodeType="tmRoot">
+          <p:childTnLst>
+            <p:seq concurrent="1" nextAc="seek">
+              <p:cTn id="2" dur="indefinite" nodeType="mainSeq">
+                <p:childTnLst>
+                  <p:par>
+                    <p:cTn id="3" fill="hold">
+                      <p:stCondLst>
+                        <p:cond delay="indefinite"/>
+                      </p:stCondLst>
+                      <p:childTnLst>
+                        <p:par>
+                          <p:cTn id="4" fill="hold">
+                            <p:stCondLst>
+                              <p:cond delay="0"/>
+                            </p:stCondLst>
+                            <p:childTnLst>
+                              <p:par>
+                                <p:cTn id="5" presetID="10" presetClass="entr" presetSubtype="0" fill="hold" grpId="0" nodeType="clickEffect">
+                                  <p:stCondLst>
+                                    <p:cond delay="0"/>
+                                  </p:stCondLst>
+                                  <p:childTnLst>
+                                    <p:set>
+                                      <p:cBhvr>
+                                        <p:cTn id="6" dur="1" fill="hold">
+                                          <p:stCondLst>
+                                            <p:cond delay="0"/>
+                                          </p:stCondLst>
+                                        </p:cTn>
+                                        <p:tgtEl>
+                                          <p:spTgt spid="7"/>
+                                        </p:tgtEl>
+                                        <p:attrNameLst>
+                                          <p:attrName>style.visibility</p:attrName>
+                                        </p:attrNameLst>
+                                      </p:cBhvr>
+                                      <p:to>
+                                        <p:strVal val="visible"/>
+                                      </p:to>
+                                    </p:set>
+                                    <p:animEffect transition="in" filter="fade">
+                                      <p:cBhvr>
+                                        <p:cTn id="7" dur="500"/>
+                                        <p:tgtEl>
+                                          <p:spTgt spid="7"/>
+                                        </p:tgtEl>
+                                      </p:cBhvr>
+                                    </p:animEffect>
+                                  </p:childTnLst>
+                                </p:cTn>
+                              </p:par>
+                              <p:par>
+                                <p:cTn id="8" presetID="10" presetClass="entr" presetSubtype="0" fill="hold" grpId="0" nodeType="withEffect">
+                                  <p:stCondLst>
+                                    <p:cond delay="0"/>
+                                  </p:stCondLst>
+                                  <p:childTnLst>
+                                    <p:set>
+                                      <p:cBhvr>
+                                        <p:cTn id="9" dur="1" fill="hold">
+                                          <p:stCondLst>
+                                            <p:cond delay="0"/>
+                                          </p:stCondLst>
+                                        </p:cTn>
+                                        <p:tgtEl>
+                                          <p:spTgt spid="8"/>
+                                        </p:tgtEl>
+                                        <p:attrNameLst>
+                                          <p:attrName>style.visibility</p:attrName>
+                                        </p:attrNameLst>
+                                      </p:cBhvr>
+                                      <p:to>
+                                        <p:strVal val="visible"/>
+                                      </p:to>
+                                    </p:set>
+                                    <p:animEffect transition="in" filter="fade">
+                                      <p:cBhvr>
+                                        <p:cTn id="10" dur="500"/>
+                                        <p:tgtEl>
+                                          <p:spTgt spid="8"/>
+                                        </p:tgtEl>
+                                      </p:cBhvr>
+                                    </p:animEffect>
+                                  </p:childTnLst>
+                                </p:cTn>
+                              </p:par>
+                              <p:par>
+                                <p:cTn id="11" presetID="10" presetClass="entr" presetSubtype="0" fill="hold" grpId="0" nodeType="withEffect">
+                                  <p:stCondLst>
+                                    <p:cond delay="0"/>
+                                  </p:stCondLst>
+                                  <p:childTnLst>
+                                    <p:set>
+                                      <p:cBhvr>
+                                        <p:cTn id="12" dur="1" fill="hold">
+                                          <p:stCondLst>
+                                            <p:cond delay="0"/>
+                                          </p:stCondLst>
+                                        </p:cTn>
+                                        <p:tgtEl>
+                                          <p:spTgt spid="9"/>
+                                        </p:tgtEl>
+                                        <p:attrNameLst>
+                                          <p:attrName>style.visibility</p:attrName>
+                                        </p:attrNameLst>
+                                      </p:cBhvr>
+                                      <p:to>
+                                        <p:strVal val="visible"/>
+                                      </p:to>
+                                    </p:set>
+                                    <p:animEffect transition="in" filter="fade">
+                                      <p:cBhvr>
+                                        <p:cTn id="13" dur="500"/>
+                                        <p:tgtEl>
+                                          <p:spTgt spid="9"/>
+                                        </p:tgtEl>
+                                      </p:cBhvr>
+                                    </p:animEffect>
+                                  </p:childTnLst>
+                                </p:cTn>
+                              </p:par>
+                            </p:childTnLst>
+                          </p:cTn>
+                        </p:par>
+                      </p:childTnLst>
+                    </p:cTn>
+                  </p:par>
+                  <p:par>
+                    <p:cTn id="14" fill="hold">
+                      <p:stCondLst>
+                        <p:cond delay="indefinite"/>
+                      </p:stCondLst>
+                      <p:childTnLst>
+                        <p:par>
+                          <p:cTn id="15" fill="hold">
+                            <p:stCondLst>
+                              <p:cond delay="0"/>
+                            </p:stCondLst>
+                            <p:childTnLst>
+                              <p:par>
+                                <p:cTn id="16" presetID="10" presetClass="entr" presetSubtype="0" fill="hold" grpId="0" nodeType="clickEffect">
+                                  <p:stCondLst>
+                                    <p:cond delay="0"/>
+                                  </p:stCondLst>
+                                  <p:childTnLst>
+                                    <p:set>
+                                      <p:cBhvr>
+                                        <p:cTn id="17" dur="1" fill="hold">
+                                          <p:stCondLst>
+                                            <p:cond delay="0"/>
+                                          </p:stCondLst>
+                                        </p:cTn>
+                                        <p:tgtEl>
+                                          <p:spTgt spid="10"/>
+                                        </p:tgtEl>
+                                        <p:attrNameLst>
+                                          <p:attrName>style.visibility</p:attrName>
+                                        </p:attrNameLst>
+                                      </p:cBhvr>
+                                      <p:to>
+                                        <p:strVal val="visible"/>
+                                      </p:to>
+                                    </p:set>
+                                    <p:animEffect transition="in" filter="fade">
+                                      <p:cBhvr>
+                                        <p:cTn id="18" dur="500"/>
+                                        <p:tgtEl>
+                                          <p:spTgt spid="10"/>
+                                        </p:tgtEl>
+                                      </p:cBhvr>
+                                    </p:animEffect>
+                                  </p:childTnLst>
+                                </p:cTn>
+                              </p:par>
+                              <p:par>
+                                <p:cTn id="19" presetID="10" presetClass="entr" presetSubtype="0" fill="hold" grpId="0" nodeType="withEffect">
+                                  <p:stCondLst>
+                                    <p:cond delay="0"/>
+                                  </p:stCondLst>
+                                  <p:childTnLst>
+                                    <p:set>
+                                      <p:cBhvr>
+                                        <p:cTn id="20" dur="1" fill="hold">
+                                          <p:stCondLst>
+                                            <p:cond delay="0"/>
+                                          </p:stCondLst>
+                                        </p:cTn>
+                                        <p:tgtEl>
+                                          <p:spTgt spid="11"/>
+                                        </p:tgtEl>
+                                        <p:attrNameLst>
+                                          <p:attrName>style.visibility</p:attrName>
+                                        </p:attrNameLst>
+                                      </p:cBhvr>
+                                      <p:to>
+                                        <p:strVal val="visible"/>
+                                      </p:to>
+                                    </p:set>
+                                    <p:animEffect transition="in" filter="fade">
+                                      <p:cBhvr>
+                                        <p:cTn id="21" dur="500"/>
+                                        <p:tgtEl>
+                                          <p:spTgt spid="11"/>
+                                        </p:tgtEl>
+                                      </p:cBhvr>
+                                    </p:animEffect>
+                                  </p:childTnLst>
+                                </p:cTn>
+                              </p:par>
+                            </p:childTnLst>
+                          </p:cTn>
+                        </p:par>
+                      </p:childTnLst>
+                    </p:cTn>
+                  </p:par>
+                  <p:par>
+                    <p:cTn id="22" fill="hold">
+                      <p:stCondLst>
+                        <p:cond delay="indefinite"/>
+                      </p:stCondLst>
+                      <p:childTnLst>
+                        <p:par>
+                          <p:cTn id="23" fill="hold">
+                            <p:stCondLst>
+                              <p:cond delay="0"/>
+                            </p:stCondLst>
+                            <p:childTnLst>
+                              <p:par>
+                                <p:cTn id="24" presetID="10" presetClass="entr" presetSubtype="0" fill="hold" grpId="0" nodeType="clickEffect">
+                                  <p:stCondLst>
+                                    <p:cond delay="0"/>
+                                  </p:stCondLst>
+                                  <p:childTnLst>
+                                    <p:set>
+                                      <p:cBhvr>
+                                        <p:cTn id="25" dur="1" fill="hold">
+                                          <p:stCondLst>
+                                            <p:cond delay="0"/>
+                                          </p:stCondLst>
+                                        </p:cTn>
+                                        <p:tgtEl>
+                                          <p:spTgt spid="12"/>
+                                        </p:tgtEl>
+                                        <p:attrNameLst>
+                                          <p:attrName>style.visibility</p:attrName>
+                                        </p:attrNameLst>
+                                      </p:cBhvr>
+                                      <p:to>
+                                        <p:strVal val="visible"/>
+                                      </p:to>
+                                    </p:set>
+                                    <p:animEffect transition="in" filter="fade">
+                                      <p:cBhvr>
+                                        <p:cTn id="26" dur="500"/>
+                                        <p:tgtEl>
+                                          <p:spTgt spid="12"/>
+                                        </p:tgtEl>
+                                      </p:cBhvr>
+                                    </p:animEffect>
+                                  </p:childTnLst>
+                                </p:cTn>
+                              </p:par>
+                              <p:par>
+                                <p:cTn id="27" presetID="10" presetClass="entr" presetSubtype="0" fill="hold" grpId="0" nodeType="withEffect">
+                                  <p:stCondLst>
+                                    <p:cond delay="0"/>
+                                  </p:stCondLst>
+                                  <p:childTnLst>
+                                    <p:set>
+                                      <p:cBhvr>
+                                        <p:cTn id="28" dur="1" fill="hold">
+                                          <p:stCondLst>
+                                            <p:cond delay="0"/>
+                                          </p:stCondLst>
+                                        </p:cTn>
+                                        <p:tgtEl>
+                                          <p:spTgt spid="13"/>
+                                        </p:tgtEl>
+                                        <p:attrNameLst>
+                                          <p:attrName>style.visibility</p:attrName>
+                                        </p:attrNameLst>
+                                      </p:cBhvr>
+                                      <p:to>
+                                        <p:strVal val="visible"/>
+                                      </p:to>
+                                    </p:set>
+                                    <p:animEffect transition="in" filter="fade">
+                                      <p:cBhvr>
+                                        <p:cTn id="29" dur="500"/>
+                                        <p:tgtEl>
+                                          <p:spTgt spid="13"/>
+                                        </p:tgtEl>
+                                      </p:cBhvr>
+                                    </p:animEffect>
+                                  </p:childTnLst>
+                                </p:cTn>
+                              </p:par>
+                              <p:par>
+                                <p:cTn id="30" presetID="10" presetClass="entr" presetSubtype="0" fill="hold" grpId="0" nodeType="withEffect">
+                                  <p:stCondLst>
+                                    <p:cond delay="0"/>
+                                  </p:stCondLst>
+                                  <p:childTnLst>
+                                    <p:set>
+                                      <p:cBhvr>
+                                        <p:cTn id="31" dur="1" fill="hold">
+                                          <p:stCondLst>
+                                            <p:cond delay="0"/>
+                                          </p:stCondLst>
+                                        </p:cTn>
+                                        <p:tgtEl>
+                                          <p:spTgt spid="14"/>
+                                        </p:tgtEl>
+                                        <p:attrNameLst>
+                                          <p:attrName>style.visibility</p:attrName>
+                                        </p:attrNameLst>
+                                      </p:cBhvr>
+                                      <p:to>
+                                        <p:strVal val="visible"/>
+                                      </p:to>
+                                    </p:set>
+                                    <p:animEffect transition="in" filter="fade">
+                                      <p:cBhvr>
+                                        <p:cTn id="32" dur="500"/>
+                                        <p:tgtEl>
+                                          <p:spTgt spid="14"/>
+                                        </p:tgtEl>
+                                      </p:cBhvr>
+                                    </p:animEffect>
+                                  </p:childTnLst>
+                                </p:cTn>
+                              </p:par>
+                              <p:par>
+                                <p:cTn id="33" presetID="10" presetClass="entr" presetSubtype="0" fill="hold" grpId="0" nodeType="withEffect">
+                                  <p:stCondLst>
+                                    <p:cond delay="0"/>
+                                  </p:stCondLst>
+                                  <p:childTnLst>
+                                    <p:set>
+                                      <p:cBhvr>
+                                        <p:cTn id="34" dur="1" fill="hold">
+                                          <p:stCondLst>
+                                            <p:cond delay="0"/>
+                                          </p:stCondLst>
+                                        </p:cTn>
+                                        <p:tgtEl>
+                                          <p:spTgt spid="15"/>
+                                        </p:tgtEl>
+                                        <p:attrNameLst>
+                                          <p:attrName>style.visibility</p:attrName>
+                                        </p:attrNameLst>
+                                      </p:cBhvr>
+                                      <p:to>
+                                        <p:strVal val="visible"/>
+                                      </p:to>
+                                    </p:set>
+                                    <p:animEffect transition="in" filter="fade">
+                                      <p:cBhvr>
+                                        <p:cTn id="35" dur="500"/>
+                                        <p:tgtEl>
+                                          <p:spTgt spid="15"/>
+                                        </p:tgtEl>
+                                      </p:cBhvr>
+                                    </p:animEffect>
+                                  </p:childTnLst>
+                                </p:cTn>
+                              </p:par>
+                              <p:par>
+                                <p:cTn id="36" presetID="10" presetClass="entr" presetSubtype="0" fill="hold" grpId="0" nodeType="withEffect">
+                                  <p:stCondLst>
+                                    <p:cond delay="0"/>
+                                  </p:stCondLst>
+                                  <p:childTnLst>
+                                    <p:set>
+                                      <p:cBhvr>
+                                        <p:cTn id="37" dur="1" fill="hold">
+                                          <p:stCondLst>
+                                            <p:cond delay="0"/>
+                                          </p:stCondLst>
+                                        </p:cTn>
+                                        <p:tgtEl>
+                                          <p:spTgt spid="16"/>
+                                        </p:tgtEl>
+                                        <p:attrNameLst>
+                                          <p:attrName>style.visibility</p:attrName>
+                                        </p:attrNameLst>
+                                      </p:cBhvr>
+                                      <p:to>
+                                        <p:strVal val="visible"/>
+                                      </p:to>
+                                    </p:set>
+                                    <p:animEffect transition="in" filter="fade">
+                                      <p:cBhvr>
+                                        <p:cTn id="38" dur="500"/>
+                                        <p:tgtEl>
+                                          <p:spTgt spid="16"/>
+                                        </p:tgtEl>
+                                      </p:cBhvr>
+                                    </p:animEffect>
+                                  </p:childTnLst>
+                                </p:cTn>
+                              </p:par>
+                              <p:par>
+                                <p:cTn id="39" presetID="10" presetClass="entr" presetSubtype="0" fill="hold" grpId="0" nodeType="withEffect">
+                                  <p:stCondLst>
+                                    <p:cond delay="0"/>
+                                  </p:stCondLst>
+                                  <p:childTnLst>
+                                    <p:set>
+                                      <p:cBhvr>
+                                        <p:cTn id="40" dur="1" fill="hold">
+                                          <p:stCondLst>
+                                            <p:cond delay="0"/>
+                                          </p:stCondLst>
+                                        </p:cTn>
+                                        <p:tgtEl>
+                                          <p:spTgt spid="17"/>
+                                        </p:tgtEl>
+                                        <p:attrNameLst>
+                                          <p:attrName>style.visibility</p:attrName>
+                                        </p:attrNameLst>
+                                      </p:cBhvr>
+                                      <p:to>
+                                        <p:strVal val="visible"/>
+                                      </p:to>
+                                    </p:set>
+                                    <p:animEffect transition="in" filter="fade">
+                                      <p:cBhvr>
+                                        <p:cTn id="41" dur="500"/>
+                                        <p:tgtEl>
+                                          <p:spTgt spid="17"/>
+                                        </p:tgtEl>
+                                      </p:cBhvr>
+                                    </p:animEffect>
+                                  </p:childTnLst>
+                                </p:cTn>
+                              </p:par>
+                              <p:par>
+                                <p:cTn id="42" presetID="10" presetClass="entr" presetSubtype="0" fill="hold" grpId="0" nodeType="withEffect">
+                                  <p:stCondLst>
+                                    <p:cond delay="0"/>
+                                  </p:stCondLst>
+                                  <p:childTnLst>
+                                    <p:set>
+                                      <p:cBhvr>
+                                        <p:cTn id="43" dur="1" fill="hold">
+                                          <p:stCondLst>
+                                            <p:cond delay="0"/>
+                                          </p:stCondLst>
+                                        </p:cTn>
+                                        <p:tgtEl>
+                                          <p:spTgt spid="18"/>
+                                        </p:tgtEl>
+                                        <p:attrNameLst>
+                                          <p:attrName>style.visibility</p:attrName>
+                                        </p:attrNameLst>
+                                      </p:cBhvr>
+                                      <p:to>
+                                        <p:strVal val="visible"/>
+                                      </p:to>
+                                    </p:set>
+                                    <p:animEffect transition="in" filter="fade">
+                                      <p:cBhvr>
+                                        <p:cTn id="44" dur="500"/>
+                                        <p:tgtEl>
+                                          <p:spTgt spid="18"/>
+                                        </p:tgtEl>
+                                      </p:cBhvr>
+                                    </p:animEffect>
+                                  </p:childTnLst>
+                                </p:cTn>
+                              </p:par>
+                              <p:par>
+                                <p:cTn id="45" presetID="10" presetClass="entr" presetSubtype="0" fill="hold" grpId="0" nodeType="withEffect">
+                                  <p:stCondLst>
+                                    <p:cond delay="0"/>
+                                  </p:stCondLst>
+                                  <p:childTnLst>
+                                    <p:set>
+                                      <p:cBhvr>
+                                        <p:cTn id="46" dur="1" fill="hold">
+                                          <p:stCondLst>
+                                            <p:cond delay="0"/>
+                                          </p:stCondLst>
+                                        </p:cTn>
+                                        <p:tgtEl>
+                                          <p:spTgt spid="19"/>
+                                        </p:tgtEl>
+                                        <p:attrNameLst>
+                                          <p:attrName>style.visibility</p:attrName>
+                                        </p:attrNameLst>
+                                      </p:cBhvr>
+                                      <p:to>
+                                        <p:strVal val="visible"/>
+                                      </p:to>
+                                    </p:set>
+                                    <p:animEffect transition="in" filter="fade">
+                                      <p:cBhvr>
+                                        <p:cTn id="47" dur="500"/>
+                                        <p:tgtEl>
+                                          <p:spTgt spid="19"/>
+                                        </p:tgtEl>
+                                      </p:cBhvr>
+                                    </p:animEffect>
+                                  </p:childTnLst>
+                                </p:cTn>
+                              </p:par>
+                            </p:childTnLst>
+                          </p:cTn>
+                        </p:par>
+                      </p:childTnLst>
+                    </p:cTn>
+                  </p:par>
+                  <p:par>
+                    <p:cTn id="48" fill="hold">
+                      <p:stCondLst>
+                        <p:cond delay="indefinite"/>
+                      </p:stCondLst>
+                      <p:childTnLst>
+                        <p:par>
+                          <p:cTn id="49" fill="hold">
+                            <p:stCondLst>
+                              <p:cond delay="0"/>
+                            </p:stCondLst>
+                            <p:childTnLst>
+                              <p:par>
+                                <p:cTn id="50" presetID="10" presetClass="entr" presetSubtype="0" fill="hold" grpId="0" nodeType="clickEffect">
+                                  <p:stCondLst>
+                                    <p:cond delay="0"/>
+                                  </p:stCondLst>
+                                  <p:childTnLst>
+                                    <p:set>
+                                      <p:cBhvr>
+                                        <p:cTn id="51" dur="1" fill="hold">
+                                          <p:stCondLst>
+                                            <p:cond delay="0"/>
+                                          </p:stCondLst>
+                                        </p:cTn>
+                                        <p:tgtEl>
+                                          <p:spTgt spid="20"/>
+                                        </p:tgtEl>
+                                        <p:attrNameLst>
+                                          <p:attrName>style.visibility</p:attrName>
+                                        </p:attrNameLst>
+                                      </p:cBhvr>
+                                      <p:to>
+                                        <p:strVal val="visible"/>
+                                      </p:to>
+                                    </p:set>
+                                    <p:animEffect transition="in" filter="fade">
+                                      <p:cBhvr>
+                                        <p:cTn id="52" dur="500"/>
+                                        <p:tgtEl>
+                                          <p:spTgt spid="20"/>
+                                        </p:tgtEl>
+                                      </p:cBhvr>
+                                    </p:animEffect>
+                                  </p:childTnLst>
+                                </p:cTn>
+                              </p:par>
+                            </p:childTnLst>
+                          </p:cTn>
+                        </p:par>
+                      </p:childTnLst>
+                    </p:cTn>
+                  </p:par>
+                </p:childTnLst>
+              </p:cTn>
+              <p:prevCondLst>
+                <p:cond evt="onPrev" delay="0">
+                  <p:tgtEl>
+                    <p:sldTgt/>
+                  </p:tgtEl>
+                </p:cond>
+              </p:prevCondLst>
+              <p:nextCondLst>
+                <p:cond evt="onNext" delay="0">
+                  <p:tgtEl>
+                    <p:sldTgt/>
+                  </p:tgtEl>
+                </p:cond>
+              </p:nextCondLst>
+            </p:seq>
+          </p:childTnLst>
+        </p:cTn>
+      </p:par>
+    </p:tnLst>
+    <p:bldLst>
+      <p:bldP spid="7" grpId="0" animBg="1"/>
+      <p:bldP spid="8" grpId="0" animBg="1"/>
+      <p:bldP spid="9" grpId="0" animBg="1"/>
+      <p:bldP spid="10" grpId="0" animBg="1"/>
+      <p:bldP spid="11" grpId="0" animBg="1"/>
+      <p:bldP spid="12" grpId="0" animBg="1"/>
+      <p:bldP spid="13" grpId="0" animBg="1"/>
+      <p:bldP spid="14" grpId="0" animBg="1"/>
+      <p:bldP spid="15" grpId="0" animBg="1"/>
+      <p:bldP spid="16" grpId="0" animBg="1"/>
+      <p:bldP spid="17" grpId="0" animBg="1"/>
+      <p:bldP spid="18" grpId="0" animBg="1"/>
+      <p:bldP spid="19" grpId="0" animBg="1"/>
+      <p:bldP spid="20" grpId="0" animBg="1"/>
+    </p:bldLst>
+  </p:timing>
 </p:sld>
 </file>
 
@@ -12162,6 +13462,452 @@
   <p:clrMapOvr>
     <a:masterClrMapping/>
   </p:clrMapOvr>
+  <p:timing>
+    <p:tnLst>
+      <p:par>
+        <p:cTn id="1" dur="indefinite" restart="never" nodeType="tmRoot">
+          <p:childTnLst>
+            <p:seq concurrent="1" nextAc="seek">
+              <p:cTn id="2" dur="indefinite" nodeType="mainSeq">
+                <p:childTnLst>
+                  <p:par>
+                    <p:cTn id="3" fill="hold">
+                      <p:stCondLst>
+                        <p:cond delay="indefinite"/>
+                      </p:stCondLst>
+                      <p:childTnLst>
+                        <p:par>
+                          <p:cTn id="4" fill="hold">
+                            <p:stCondLst>
+                              <p:cond delay="0"/>
+                            </p:stCondLst>
+                            <p:childTnLst>
+                              <p:par>
+                                <p:cTn id="5" presetID="10" presetClass="entr" presetSubtype="0" fill="hold" grpId="0" nodeType="clickEffect">
+                                  <p:stCondLst>
+                                    <p:cond delay="0"/>
+                                  </p:stCondLst>
+                                  <p:childTnLst>
+                                    <p:set>
+                                      <p:cBhvr>
+                                        <p:cTn id="6" dur="1" fill="hold">
+                                          <p:stCondLst>
+                                            <p:cond delay="0"/>
+                                          </p:stCondLst>
+                                        </p:cTn>
+                                        <p:tgtEl>
+                                          <p:spTgt spid="28"/>
+                                        </p:tgtEl>
+                                        <p:attrNameLst>
+                                          <p:attrName>style.visibility</p:attrName>
+                                        </p:attrNameLst>
+                                      </p:cBhvr>
+                                      <p:to>
+                                        <p:strVal val="visible"/>
+                                      </p:to>
+                                    </p:set>
+                                    <p:animEffect transition="in" filter="fade">
+                                      <p:cBhvr>
+                                        <p:cTn id="7" dur="500"/>
+                                        <p:tgtEl>
+                                          <p:spTgt spid="28"/>
+                                        </p:tgtEl>
+                                      </p:cBhvr>
+                                    </p:animEffect>
+                                  </p:childTnLst>
+                                </p:cTn>
+                              </p:par>
+                              <p:par>
+                                <p:cTn id="8" presetID="10" presetClass="entr" presetSubtype="0" fill="hold" grpId="0" nodeType="withEffect">
+                                  <p:stCondLst>
+                                    <p:cond delay="0"/>
+                                  </p:stCondLst>
+                                  <p:childTnLst>
+                                    <p:set>
+                                      <p:cBhvr>
+                                        <p:cTn id="9" dur="1" fill="hold">
+                                          <p:stCondLst>
+                                            <p:cond delay="0"/>
+                                          </p:stCondLst>
+                                        </p:cTn>
+                                        <p:tgtEl>
+                                          <p:spTgt spid="15"/>
+                                        </p:tgtEl>
+                                        <p:attrNameLst>
+                                          <p:attrName>style.visibility</p:attrName>
+                                        </p:attrNameLst>
+                                      </p:cBhvr>
+                                      <p:to>
+                                        <p:strVal val="visible"/>
+                                      </p:to>
+                                    </p:set>
+                                    <p:animEffect transition="in" filter="fade">
+                                      <p:cBhvr>
+                                        <p:cTn id="10" dur="500"/>
+                                        <p:tgtEl>
+                                          <p:spTgt spid="15"/>
+                                        </p:tgtEl>
+                                      </p:cBhvr>
+                                    </p:animEffect>
+                                  </p:childTnLst>
+                                </p:cTn>
+                              </p:par>
+                              <p:par>
+                                <p:cTn id="11" presetID="10" presetClass="entr" presetSubtype="0" fill="hold" grpId="0" nodeType="withEffect">
+                                  <p:stCondLst>
+                                    <p:cond delay="0"/>
+                                  </p:stCondLst>
+                                  <p:childTnLst>
+                                    <p:set>
+                                      <p:cBhvr>
+                                        <p:cTn id="12" dur="1" fill="hold">
+                                          <p:stCondLst>
+                                            <p:cond delay="0"/>
+                                          </p:stCondLst>
+                                        </p:cTn>
+                                        <p:tgtEl>
+                                          <p:spTgt spid="16"/>
+                                        </p:tgtEl>
+                                        <p:attrNameLst>
+                                          <p:attrName>style.visibility</p:attrName>
+                                        </p:attrNameLst>
+                                      </p:cBhvr>
+                                      <p:to>
+                                        <p:strVal val="visible"/>
+                                      </p:to>
+                                    </p:set>
+                                    <p:animEffect transition="in" filter="fade">
+                                      <p:cBhvr>
+                                        <p:cTn id="13" dur="500"/>
+                                        <p:tgtEl>
+                                          <p:spTgt spid="16"/>
+                                        </p:tgtEl>
+                                      </p:cBhvr>
+                                    </p:animEffect>
+                                  </p:childTnLst>
+                                </p:cTn>
+                              </p:par>
+                              <p:par>
+                                <p:cTn id="14" presetID="10" presetClass="entr" presetSubtype="0" fill="hold" grpId="0" nodeType="withEffect">
+                                  <p:stCondLst>
+                                    <p:cond delay="0"/>
+                                  </p:stCondLst>
+                                  <p:childTnLst>
+                                    <p:set>
+                                      <p:cBhvr>
+                                        <p:cTn id="15" dur="1" fill="hold">
+                                          <p:stCondLst>
+                                            <p:cond delay="0"/>
+                                          </p:stCondLst>
+                                        </p:cTn>
+                                        <p:tgtEl>
+                                          <p:spTgt spid="17"/>
+                                        </p:tgtEl>
+                                        <p:attrNameLst>
+                                          <p:attrName>style.visibility</p:attrName>
+                                        </p:attrNameLst>
+                                      </p:cBhvr>
+                                      <p:to>
+                                        <p:strVal val="visible"/>
+                                      </p:to>
+                                    </p:set>
+                                    <p:animEffect transition="in" filter="fade">
+                                      <p:cBhvr>
+                                        <p:cTn id="16" dur="500"/>
+                                        <p:tgtEl>
+                                          <p:spTgt spid="17"/>
+                                        </p:tgtEl>
+                                      </p:cBhvr>
+                                    </p:animEffect>
+                                  </p:childTnLst>
+                                </p:cTn>
+                              </p:par>
+                              <p:par>
+                                <p:cTn id="17" presetID="10" presetClass="entr" presetSubtype="0" fill="hold" grpId="0" nodeType="withEffect">
+                                  <p:stCondLst>
+                                    <p:cond delay="0"/>
+                                  </p:stCondLst>
+                                  <p:childTnLst>
+                                    <p:set>
+                                      <p:cBhvr>
+                                        <p:cTn id="18" dur="1" fill="hold">
+                                          <p:stCondLst>
+                                            <p:cond delay="0"/>
+                                          </p:stCondLst>
+                                        </p:cTn>
+                                        <p:tgtEl>
+                                          <p:spTgt spid="18"/>
+                                        </p:tgtEl>
+                                        <p:attrNameLst>
+                                          <p:attrName>style.visibility</p:attrName>
+                                        </p:attrNameLst>
+                                      </p:cBhvr>
+                                      <p:to>
+                                        <p:strVal val="visible"/>
+                                      </p:to>
+                                    </p:set>
+                                    <p:animEffect transition="in" filter="fade">
+                                      <p:cBhvr>
+                                        <p:cTn id="19" dur="500"/>
+                                        <p:tgtEl>
+                                          <p:spTgt spid="18"/>
+                                        </p:tgtEl>
+                                      </p:cBhvr>
+                                    </p:animEffect>
+                                  </p:childTnLst>
+                                </p:cTn>
+                              </p:par>
+                              <p:par>
+                                <p:cTn id="20" presetID="10" presetClass="entr" presetSubtype="0" fill="hold" grpId="0" nodeType="withEffect">
+                                  <p:stCondLst>
+                                    <p:cond delay="0"/>
+                                  </p:stCondLst>
+                                  <p:childTnLst>
+                                    <p:set>
+                                      <p:cBhvr>
+                                        <p:cTn id="21" dur="1" fill="hold">
+                                          <p:stCondLst>
+                                            <p:cond delay="0"/>
+                                          </p:stCondLst>
+                                        </p:cTn>
+                                        <p:tgtEl>
+                                          <p:spTgt spid="19"/>
+                                        </p:tgtEl>
+                                        <p:attrNameLst>
+                                          <p:attrName>style.visibility</p:attrName>
+                                        </p:attrNameLst>
+                                      </p:cBhvr>
+                                      <p:to>
+                                        <p:strVal val="visible"/>
+                                      </p:to>
+                                    </p:set>
+                                    <p:animEffect transition="in" filter="fade">
+                                      <p:cBhvr>
+                                        <p:cTn id="22" dur="500"/>
+                                        <p:tgtEl>
+                                          <p:spTgt spid="19"/>
+                                        </p:tgtEl>
+                                      </p:cBhvr>
+                                    </p:animEffect>
+                                  </p:childTnLst>
+                                </p:cTn>
+                              </p:par>
+                              <p:par>
+                                <p:cTn id="23" presetID="10" presetClass="entr" presetSubtype="0" fill="hold" grpId="0" nodeType="withEffect">
+                                  <p:stCondLst>
+                                    <p:cond delay="0"/>
+                                  </p:stCondLst>
+                                  <p:childTnLst>
+                                    <p:set>
+                                      <p:cBhvr>
+                                        <p:cTn id="24" dur="1" fill="hold">
+                                          <p:stCondLst>
+                                            <p:cond delay="0"/>
+                                          </p:stCondLst>
+                                        </p:cTn>
+                                        <p:tgtEl>
+                                          <p:spTgt spid="20"/>
+                                        </p:tgtEl>
+                                        <p:attrNameLst>
+                                          <p:attrName>style.visibility</p:attrName>
+                                        </p:attrNameLst>
+                                      </p:cBhvr>
+                                      <p:to>
+                                        <p:strVal val="visible"/>
+                                      </p:to>
+                                    </p:set>
+                                    <p:animEffect transition="in" filter="fade">
+                                      <p:cBhvr>
+                                        <p:cTn id="25" dur="500"/>
+                                        <p:tgtEl>
+                                          <p:spTgt spid="20"/>
+                                        </p:tgtEl>
+                                      </p:cBhvr>
+                                    </p:animEffect>
+                                  </p:childTnLst>
+                                </p:cTn>
+                              </p:par>
+                              <p:par>
+                                <p:cTn id="26" presetID="10" presetClass="entr" presetSubtype="0" fill="hold" grpId="0" nodeType="withEffect">
+                                  <p:stCondLst>
+                                    <p:cond delay="0"/>
+                                  </p:stCondLst>
+                                  <p:childTnLst>
+                                    <p:set>
+                                      <p:cBhvr>
+                                        <p:cTn id="27" dur="1" fill="hold">
+                                          <p:stCondLst>
+                                            <p:cond delay="0"/>
+                                          </p:stCondLst>
+                                        </p:cTn>
+                                        <p:tgtEl>
+                                          <p:spTgt spid="21"/>
+                                        </p:tgtEl>
+                                        <p:attrNameLst>
+                                          <p:attrName>style.visibility</p:attrName>
+                                        </p:attrNameLst>
+                                      </p:cBhvr>
+                                      <p:to>
+                                        <p:strVal val="visible"/>
+                                      </p:to>
+                                    </p:set>
+                                    <p:animEffect transition="in" filter="fade">
+                                      <p:cBhvr>
+                                        <p:cTn id="28" dur="500"/>
+                                        <p:tgtEl>
+                                          <p:spTgt spid="21"/>
+                                        </p:tgtEl>
+                                      </p:cBhvr>
+                                    </p:animEffect>
+                                  </p:childTnLst>
+                                </p:cTn>
+                              </p:par>
+                              <p:par>
+                                <p:cTn id="29" presetID="10" presetClass="entr" presetSubtype="0" fill="hold" grpId="0" nodeType="withEffect">
+                                  <p:stCondLst>
+                                    <p:cond delay="0"/>
+                                  </p:stCondLst>
+                                  <p:childTnLst>
+                                    <p:set>
+                                      <p:cBhvr>
+                                        <p:cTn id="30" dur="1" fill="hold">
+                                          <p:stCondLst>
+                                            <p:cond delay="0"/>
+                                          </p:stCondLst>
+                                        </p:cTn>
+                                        <p:tgtEl>
+                                          <p:spTgt spid="22"/>
+                                        </p:tgtEl>
+                                        <p:attrNameLst>
+                                          <p:attrName>style.visibility</p:attrName>
+                                        </p:attrNameLst>
+                                      </p:cBhvr>
+                                      <p:to>
+                                        <p:strVal val="visible"/>
+                                      </p:to>
+                                    </p:set>
+                                    <p:animEffect transition="in" filter="fade">
+                                      <p:cBhvr>
+                                        <p:cTn id="31" dur="500"/>
+                                        <p:tgtEl>
+                                          <p:spTgt spid="22"/>
+                                        </p:tgtEl>
+                                      </p:cBhvr>
+                                    </p:animEffect>
+                                  </p:childTnLst>
+                                </p:cTn>
+                              </p:par>
+                              <p:par>
+                                <p:cTn id="32" presetID="10" presetClass="entr" presetSubtype="0" fill="hold" grpId="0" nodeType="withEffect">
+                                  <p:stCondLst>
+                                    <p:cond delay="0"/>
+                                  </p:stCondLst>
+                                  <p:childTnLst>
+                                    <p:set>
+                                      <p:cBhvr>
+                                        <p:cTn id="33" dur="1" fill="hold">
+                                          <p:stCondLst>
+                                            <p:cond delay="0"/>
+                                          </p:stCondLst>
+                                        </p:cTn>
+                                        <p:tgtEl>
+                                          <p:spTgt spid="23"/>
+                                        </p:tgtEl>
+                                        <p:attrNameLst>
+                                          <p:attrName>style.visibility</p:attrName>
+                                        </p:attrNameLst>
+                                      </p:cBhvr>
+                                      <p:to>
+                                        <p:strVal val="visible"/>
+                                      </p:to>
+                                    </p:set>
+                                    <p:animEffect transition="in" filter="fade">
+                                      <p:cBhvr>
+                                        <p:cTn id="34" dur="500"/>
+                                        <p:tgtEl>
+                                          <p:spTgt spid="23"/>
+                                        </p:tgtEl>
+                                      </p:cBhvr>
+                                    </p:animEffect>
+                                  </p:childTnLst>
+                                </p:cTn>
+                              </p:par>
+                              <p:par>
+                                <p:cTn id="35" presetID="10" presetClass="entr" presetSubtype="0" fill="hold" grpId="0" nodeType="withEffect">
+                                  <p:stCondLst>
+                                    <p:cond delay="0"/>
+                                  </p:stCondLst>
+                                  <p:childTnLst>
+                                    <p:set>
+                                      <p:cBhvr>
+                                        <p:cTn id="36" dur="1" fill="hold">
+                                          <p:stCondLst>
+                                            <p:cond delay="0"/>
+                                          </p:stCondLst>
+                                        </p:cTn>
+                                        <p:tgtEl>
+                                          <p:spTgt spid="24"/>
+                                        </p:tgtEl>
+                                        <p:attrNameLst>
+                                          <p:attrName>style.visibility</p:attrName>
+                                        </p:attrNameLst>
+                                      </p:cBhvr>
+                                      <p:to>
+                                        <p:strVal val="visible"/>
+                                      </p:to>
+                                    </p:set>
+                                    <p:animEffect transition="in" filter="fade">
+                                      <p:cBhvr>
+                                        <p:cTn id="37" dur="500"/>
+                                        <p:tgtEl>
+                                          <p:spTgt spid="24"/>
+                                        </p:tgtEl>
+                                      </p:cBhvr>
+                                    </p:animEffect>
+                                  </p:childTnLst>
+                                </p:cTn>
+                              </p:par>
+                            </p:childTnLst>
+                          </p:cTn>
+                        </p:par>
+                      </p:childTnLst>
+                    </p:cTn>
+                  </p:par>
+                </p:childTnLst>
+              </p:cTn>
+              <p:prevCondLst>
+                <p:cond evt="onPrev" delay="0">
+                  <p:tgtEl>
+                    <p:sldTgt/>
+                  </p:tgtEl>
+                </p:cond>
+              </p:prevCondLst>
+              <p:nextCondLst>
+                <p:cond evt="onNext" delay="0">
+                  <p:tgtEl>
+                    <p:sldTgt/>
+                  </p:tgtEl>
+                </p:cond>
+              </p:nextCondLst>
+            </p:seq>
+          </p:childTnLst>
+        </p:cTn>
+      </p:par>
+    </p:tnLst>
+    <p:bldLst>
+      <p:bldP spid="28" grpId="0" animBg="1"/>
+      <p:bldP spid="15" grpId="0" animBg="1"/>
+      <p:bldP spid="16" grpId="0" animBg="1"/>
+      <p:bldP spid="17" grpId="0" animBg="1"/>
+      <p:bldP spid="18" grpId="0" animBg="1"/>
+      <p:bldP spid="19" grpId="0" animBg="1"/>
+      <p:bldP spid="20" grpId="0" animBg="1"/>
+      <p:bldP spid="21" grpId="0" animBg="1"/>
+      <p:bldP spid="22" grpId="0" animBg="1"/>
+      <p:bldP spid="23" grpId="0" animBg="1"/>
+      <p:bldP spid="24" grpId="0" animBg="1"/>
+    </p:bldLst>
+  </p:timing>
 </p:sld>
 </file>
 
@@ -12285,7 +14031,7 @@
                   <a:srgbClr val="172C3A"/>
                 </a:solidFill>
               </a:rPr>
-              <a:t>Test before training</a:t>
+              <a:t>Load pretrained BERT</a:t>
             </a:r>
             <a:endParaRPr lang="en-US" sz="3400" noProof="0" dirty="0"/>
           </a:p>
@@ -13226,7 +14972,13 @@
   <p:cSld>
     <p:spTree>
       <p:nvGrpSpPr>
-        <p:cNvPr id="1" name=""/>
+        <p:cNvPr id="1" name="">
+          <a:extLst>
+            <a:ext uri="{FF2B5EF4-FFF2-40B4-BE49-F238E27FC236}">
+              <a16:creationId xmlns:a16="http://schemas.microsoft.com/office/drawing/2014/main" id="{BCC30999-B15B-1DE3-5AF9-B13779003E29}"/>
+            </a:ext>
+          </a:extLst>
+        </p:cNvPr>
         <p:cNvGrpSpPr/>
         <p:nvPr/>
       </p:nvGrpSpPr>
@@ -13240,66 +14992,1020 @@
       </p:grpSpPr>
       <p:sp>
         <p:nvSpPr>
-          <p:cNvPr id="2" name="Cím 1">
+          <p:cNvPr id="2" name="Text 0">
             <a:extLst>
               <a:ext uri="{FF2B5EF4-FFF2-40B4-BE49-F238E27FC236}">
-                <a16:creationId xmlns:a16="http://schemas.microsoft.com/office/drawing/2014/main" id="{F5F32A51-CFBF-E980-BE9B-7FF7C9C1DCB2}"/>
+                <a16:creationId xmlns:a16="http://schemas.microsoft.com/office/drawing/2014/main" id="{160D541C-6E7F-E028-7E93-38E73A9ABF48}"/>
               </a:ext>
             </a:extLst>
           </p:cNvPr>
-          <p:cNvSpPr>
-            <a:spLocks noGrp="1"/>
-          </p:cNvSpPr>
-          <p:nvPr>
-            <p:ph type="title"/>
-          </p:nvPr>
-        </p:nvSpPr>
-        <p:spPr/>
-        <p:txBody>
-          <a:bodyPr/>
+          <p:cNvSpPr/>
+          <p:nvPr/>
+        </p:nvSpPr>
+        <p:spPr>
+          <a:xfrm>
+            <a:off x="1133782" y="823353"/>
+            <a:ext cx="22127039" cy="822906"/>
+          </a:xfrm>
+          <a:prstGeom prst="rect">
+            <a:avLst/>
+          </a:prstGeom>
+          <a:noFill/>
+          <a:ln/>
+        </p:spPr>
+        <p:txBody>
+          <a:bodyPr wrap="square" lIns="0" tIns="0" rIns="0" bIns="0" rtlCol="0" anchor="ctr"/>
           <a:lstStyle/>
           <a:p>
             <a:r>
-              <a:rPr lang="en-US" dirty="0"/>
-              <a:t>https://shorturl.at/XaYtE</a:t>
-            </a:r>
-          </a:p>
-        </p:txBody>
-      </p:sp>
-      <p:sp>
-        <p:nvSpPr>
-          <p:cNvPr id="4" name="Élőláb helye 3">
+              <a:rPr lang="en-US" sz="6200" b="1" noProof="0" dirty="0">
+                <a:solidFill>
+                  <a:srgbClr val="172C3A"/>
+                </a:solidFill>
+                <a:latin typeface="Aptos Display" pitchFamily="34" charset="0"/>
+                <a:ea typeface="Aptos Display" pitchFamily="34" charset="-122"/>
+                <a:cs typeface="Aptos Display" pitchFamily="34" charset="-120"/>
+              </a:rPr>
+              <a:t>How to reach the material</a:t>
+            </a:r>
+            <a:endParaRPr lang="en-US" sz="6200" noProof="0" dirty="0"/>
+          </a:p>
+        </p:txBody>
+      </p:sp>
+      <p:sp>
+        <p:nvSpPr>
+          <p:cNvPr id="4" name="Text 2">
             <a:extLst>
               <a:ext uri="{FF2B5EF4-FFF2-40B4-BE49-F238E27FC236}">
-                <a16:creationId xmlns:a16="http://schemas.microsoft.com/office/drawing/2014/main" id="{7366ECF3-8EAD-EFB2-7F16-6046A647AAF6}"/>
+                <a16:creationId xmlns:a16="http://schemas.microsoft.com/office/drawing/2014/main" id="{A8FCBABE-1825-D3B4-3FC9-B387CD78504A}"/>
               </a:ext>
             </a:extLst>
           </p:cNvPr>
-          <p:cNvSpPr>
-            <a:spLocks noGrp="1"/>
-          </p:cNvSpPr>
-          <p:nvPr>
-            <p:ph type="ftr" sz="quarter" idx="11"/>
-          </p:nvPr>
-        </p:nvSpPr>
-        <p:spPr/>
+          <p:cNvSpPr/>
+          <p:nvPr/>
+        </p:nvSpPr>
+        <p:spPr>
+          <a:xfrm>
+            <a:off x="2102983" y="2997396"/>
+            <a:ext cx="768046" cy="768046"/>
+          </a:xfrm>
+          <a:prstGeom prst="ellipse">
+            <a:avLst/>
+          </a:prstGeom>
+          <a:solidFill>
+            <a:srgbClr val="087D7D"/>
+          </a:solidFill>
+          <a:ln>
+            <a:solidFill>
+              <a:srgbClr val="087D7D"/>
+            </a:solidFill>
+          </a:ln>
+        </p:spPr>
+        <p:txBody>
+          <a:bodyPr wrap="square" lIns="0" tIns="0" rIns="0" bIns="0" rtlCol="0" anchor="ctr"/>
+          <a:lstStyle/>
+          <a:p>
+            <a:pPr algn="ctr"/>
+            <a:r>
+              <a:rPr lang="en-US" sz="3000" b="1" noProof="0" dirty="0">
+                <a:solidFill>
+                  <a:srgbClr val="FFFFFF"/>
+                </a:solidFill>
+              </a:rPr>
+              <a:t>1</a:t>
+            </a:r>
+            <a:endParaRPr lang="en-US" sz="3000" noProof="0" dirty="0"/>
+          </a:p>
+        </p:txBody>
+      </p:sp>
+      <p:sp>
+        <p:nvSpPr>
+          <p:cNvPr id="5" name="Text 3">
+            <a:extLst>
+              <a:ext uri="{FF2B5EF4-FFF2-40B4-BE49-F238E27FC236}">
+                <a16:creationId xmlns:a16="http://schemas.microsoft.com/office/drawing/2014/main" id="{76F7F649-CAF1-AA89-A407-FA26B82E14E7}"/>
+              </a:ext>
+            </a:extLst>
+          </p:cNvPr>
+          <p:cNvSpPr/>
+          <p:nvPr/>
+        </p:nvSpPr>
+        <p:spPr>
+          <a:xfrm>
+            <a:off x="3328199" y="3088842"/>
+            <a:ext cx="14829172" cy="498597"/>
+          </a:xfrm>
+          <a:prstGeom prst="rect">
+            <a:avLst/>
+          </a:prstGeom>
+          <a:noFill/>
+          <a:ln/>
+        </p:spPr>
+        <p:txBody>
+          <a:bodyPr wrap="square" lIns="0" tIns="0" rIns="0" bIns="0" rtlCol="0" anchor="ctr"/>
+          <a:lstStyle/>
+          <a:p>
+            <a:r>
+              <a:rPr lang="en-US" sz="3600" noProof="0" dirty="0"/>
+              <a:t>https://shorturl.at/XaYtE</a:t>
+            </a:r>
+            <a:endParaRPr lang="en-US" sz="3400" noProof="0" dirty="0"/>
+          </a:p>
+        </p:txBody>
+      </p:sp>
+      <p:sp>
+        <p:nvSpPr>
+          <p:cNvPr id="7" name="Shape 5">
+            <a:extLst>
+              <a:ext uri="{FF2B5EF4-FFF2-40B4-BE49-F238E27FC236}">
+                <a16:creationId xmlns:a16="http://schemas.microsoft.com/office/drawing/2014/main" id="{EEF860F0-F881-C67A-7667-F1F9A559ADD5}"/>
+              </a:ext>
+            </a:extLst>
+          </p:cNvPr>
+          <p:cNvSpPr/>
+          <p:nvPr/>
+        </p:nvSpPr>
+        <p:spPr>
+          <a:xfrm>
+            <a:off x="2487006" y="3856877"/>
+            <a:ext cx="0" cy="475457"/>
+          </a:xfrm>
+          <a:prstGeom prst="line">
+            <a:avLst/>
+          </a:prstGeom>
+          <a:noFill/>
+          <a:ln w="15240">
+            <a:solidFill>
+              <a:srgbClr val="D0D8DD"/>
+            </a:solidFill>
+            <a:prstDash val="solid"/>
+          </a:ln>
+        </p:spPr>
         <p:txBody>
           <a:bodyPr/>
           <a:lstStyle/>
           <a:p>
-            <a:pPr algn="l"/>
-            <a:r>
-              <a:rPr lang="en-US" sz="3200" dirty="0"/>
+            <a:endParaRPr lang="en-US" sz="3600" noProof="0" dirty="0"/>
+          </a:p>
+        </p:txBody>
+      </p:sp>
+      <p:sp>
+        <p:nvSpPr>
+          <p:cNvPr id="8" name="Text 6">
+            <a:extLst>
+              <a:ext uri="{FF2B5EF4-FFF2-40B4-BE49-F238E27FC236}">
+                <a16:creationId xmlns:a16="http://schemas.microsoft.com/office/drawing/2014/main" id="{40687218-B213-9561-21DA-F3572D654CF3}"/>
+              </a:ext>
+            </a:extLst>
+          </p:cNvPr>
+          <p:cNvSpPr/>
+          <p:nvPr/>
+        </p:nvSpPr>
+        <p:spPr>
+          <a:xfrm>
+            <a:off x="2102983" y="4423768"/>
+            <a:ext cx="768046" cy="768046"/>
+          </a:xfrm>
+          <a:prstGeom prst="ellipse">
+            <a:avLst/>
+          </a:prstGeom>
+          <a:solidFill>
+            <a:srgbClr val="087D7D"/>
+          </a:solidFill>
+          <a:ln>
+            <a:solidFill>
+              <a:srgbClr val="087D7D"/>
+            </a:solidFill>
+          </a:ln>
+        </p:spPr>
+        <p:txBody>
+          <a:bodyPr wrap="square" lIns="0" tIns="0" rIns="0" bIns="0" rtlCol="0" anchor="ctr"/>
+          <a:lstStyle/>
+          <a:p>
+            <a:pPr algn="ctr"/>
+            <a:r>
+              <a:rPr lang="en-US" sz="3000" b="1" noProof="0" dirty="0">
+                <a:solidFill>
+                  <a:srgbClr val="FFFFFF"/>
+                </a:solidFill>
+              </a:rPr>
+              <a:t>2</a:t>
+            </a:r>
+            <a:endParaRPr lang="en-US" sz="3000" noProof="0" dirty="0"/>
+          </a:p>
+        </p:txBody>
+      </p:sp>
+      <p:sp>
+        <p:nvSpPr>
+          <p:cNvPr id="9" name="Text 7">
+            <a:extLst>
+              <a:ext uri="{FF2B5EF4-FFF2-40B4-BE49-F238E27FC236}">
+                <a16:creationId xmlns:a16="http://schemas.microsoft.com/office/drawing/2014/main" id="{E34B6DB2-63D1-A9CF-BD1A-99BDD3D5689C}"/>
+              </a:ext>
+            </a:extLst>
+          </p:cNvPr>
+          <p:cNvSpPr/>
+          <p:nvPr/>
+        </p:nvSpPr>
+        <p:spPr>
+          <a:xfrm>
+            <a:off x="3328199" y="4515213"/>
+            <a:ext cx="14829172" cy="498597"/>
+          </a:xfrm>
+          <a:prstGeom prst="rect">
+            <a:avLst/>
+          </a:prstGeom>
+          <a:noFill/>
+          <a:ln/>
+        </p:spPr>
+        <p:txBody>
+          <a:bodyPr wrap="square" lIns="0" tIns="0" rIns="0" bIns="0" rtlCol="0" anchor="ctr"/>
+          <a:lstStyle/>
+          <a:p>
+            <a:r>
+              <a:rPr lang="en-US" sz="3400" b="1" noProof="0" dirty="0">
+                <a:solidFill>
+                  <a:srgbClr val="172C3A"/>
+                </a:solidFill>
+              </a:rPr>
+              <a:t>Go to the </a:t>
+            </a:r>
+            <a:r>
+              <a:rPr lang="en-US" sz="3400" b="1" noProof="0" dirty="0" err="1">
+                <a:solidFill>
+                  <a:srgbClr val="172C3A"/>
+                </a:solidFill>
+              </a:rPr>
+              <a:t>nlp_explainability</a:t>
+            </a:r>
+            <a:r>
+              <a:rPr lang="en-US" sz="3400" b="1" noProof="0" dirty="0">
+                <a:solidFill>
+                  <a:srgbClr val="172C3A"/>
+                </a:solidFill>
+              </a:rPr>
+              <a:t> folder</a:t>
+            </a:r>
+            <a:endParaRPr lang="en-US" sz="3400" noProof="0" dirty="0"/>
+          </a:p>
+        </p:txBody>
+      </p:sp>
+      <p:sp>
+        <p:nvSpPr>
+          <p:cNvPr id="11" name="Shape 9">
+            <a:extLst>
+              <a:ext uri="{FF2B5EF4-FFF2-40B4-BE49-F238E27FC236}">
+                <a16:creationId xmlns:a16="http://schemas.microsoft.com/office/drawing/2014/main" id="{EA2F15C3-A0EF-1447-A74B-C212CC17B07D}"/>
+              </a:ext>
+            </a:extLst>
+          </p:cNvPr>
+          <p:cNvSpPr/>
+          <p:nvPr/>
+        </p:nvSpPr>
+        <p:spPr>
+          <a:xfrm>
+            <a:off x="2487006" y="5283248"/>
+            <a:ext cx="0" cy="475457"/>
+          </a:xfrm>
+          <a:prstGeom prst="line">
+            <a:avLst/>
+          </a:prstGeom>
+          <a:noFill/>
+          <a:ln w="15240">
+            <a:solidFill>
+              <a:srgbClr val="D0D8DD"/>
+            </a:solidFill>
+            <a:prstDash val="solid"/>
+          </a:ln>
+        </p:spPr>
+        <p:txBody>
+          <a:bodyPr/>
+          <a:lstStyle/>
+          <a:p>
+            <a:endParaRPr lang="en-US" sz="3600" noProof="0" dirty="0"/>
+          </a:p>
+        </p:txBody>
+      </p:sp>
+      <p:sp>
+        <p:nvSpPr>
+          <p:cNvPr id="12" name="Text 10">
+            <a:extLst>
+              <a:ext uri="{FF2B5EF4-FFF2-40B4-BE49-F238E27FC236}">
+                <a16:creationId xmlns:a16="http://schemas.microsoft.com/office/drawing/2014/main" id="{D41ACFC1-70D1-D6E8-071C-2035C464BE29}"/>
+              </a:ext>
+            </a:extLst>
+          </p:cNvPr>
+          <p:cNvSpPr/>
+          <p:nvPr/>
+        </p:nvSpPr>
+        <p:spPr>
+          <a:xfrm>
+            <a:off x="2102983" y="5850139"/>
+            <a:ext cx="768046" cy="768046"/>
+          </a:xfrm>
+          <a:prstGeom prst="ellipse">
+            <a:avLst/>
+          </a:prstGeom>
+          <a:solidFill>
+            <a:srgbClr val="087D7D"/>
+          </a:solidFill>
+          <a:ln>
+            <a:solidFill>
+              <a:srgbClr val="087D7D"/>
+            </a:solidFill>
+          </a:ln>
+        </p:spPr>
+        <p:txBody>
+          <a:bodyPr wrap="square" lIns="0" tIns="0" rIns="0" bIns="0" rtlCol="0" anchor="ctr"/>
+          <a:lstStyle/>
+          <a:p>
+            <a:pPr algn="ctr"/>
+            <a:r>
+              <a:rPr lang="en-US" sz="3000" b="1" noProof="0" dirty="0">
+                <a:solidFill>
+                  <a:srgbClr val="FFFFFF"/>
+                </a:solidFill>
+              </a:rPr>
+              <a:t>3</a:t>
+            </a:r>
+            <a:endParaRPr lang="en-US" sz="3000" noProof="0" dirty="0"/>
+          </a:p>
+        </p:txBody>
+      </p:sp>
+      <p:sp>
+        <p:nvSpPr>
+          <p:cNvPr id="13" name="Text 11">
+            <a:extLst>
+              <a:ext uri="{FF2B5EF4-FFF2-40B4-BE49-F238E27FC236}">
+                <a16:creationId xmlns:a16="http://schemas.microsoft.com/office/drawing/2014/main" id="{4A13B37E-5A65-FFB4-7BED-86934638DB06}"/>
+              </a:ext>
+            </a:extLst>
+          </p:cNvPr>
+          <p:cNvSpPr/>
+          <p:nvPr/>
+        </p:nvSpPr>
+        <p:spPr>
+          <a:xfrm>
+            <a:off x="3328199" y="5941585"/>
+            <a:ext cx="14829172" cy="498597"/>
+          </a:xfrm>
+          <a:prstGeom prst="rect">
+            <a:avLst/>
+          </a:prstGeom>
+          <a:noFill/>
+          <a:ln/>
+        </p:spPr>
+        <p:txBody>
+          <a:bodyPr wrap="square" lIns="0" tIns="0" rIns="0" bIns="0" rtlCol="0" anchor="ctr"/>
+          <a:lstStyle/>
+          <a:p>
+            <a:r>
+              <a:rPr lang="en-US" sz="3400" b="1" noProof="0" dirty="0">
+                <a:solidFill>
+                  <a:srgbClr val="172C3A"/>
+                </a:solidFill>
+              </a:rPr>
+              <a:t>Open the notebook: </a:t>
+            </a:r>
+            <a:r>
+              <a:rPr lang="en-US" sz="3400" b="1" noProof="0" dirty="0" err="1">
+                <a:solidFill>
+                  <a:srgbClr val="172C3A"/>
+                </a:solidFill>
+              </a:rPr>
+              <a:t>bert_finetuning.ipynb</a:t>
+            </a:r>
+            <a:endParaRPr lang="en-US" sz="3400" noProof="0" dirty="0"/>
+          </a:p>
+        </p:txBody>
+      </p:sp>
+      <p:sp>
+        <p:nvSpPr>
+          <p:cNvPr id="15" name="Shape 13">
+            <a:extLst>
+              <a:ext uri="{FF2B5EF4-FFF2-40B4-BE49-F238E27FC236}">
+                <a16:creationId xmlns:a16="http://schemas.microsoft.com/office/drawing/2014/main" id="{F413AEC3-9F33-02FA-ABBB-EED1CE14F3D8}"/>
+              </a:ext>
+            </a:extLst>
+          </p:cNvPr>
+          <p:cNvSpPr/>
+          <p:nvPr/>
+        </p:nvSpPr>
+        <p:spPr>
+          <a:xfrm>
+            <a:off x="2487006" y="6709619"/>
+            <a:ext cx="0" cy="475457"/>
+          </a:xfrm>
+          <a:prstGeom prst="line">
+            <a:avLst/>
+          </a:prstGeom>
+          <a:noFill/>
+          <a:ln w="15240">
+            <a:solidFill>
+              <a:srgbClr val="D0D8DD"/>
+            </a:solidFill>
+            <a:prstDash val="solid"/>
+          </a:ln>
+        </p:spPr>
+        <p:txBody>
+          <a:bodyPr/>
+          <a:lstStyle/>
+          <a:p>
+            <a:endParaRPr lang="en-US" sz="3600" noProof="0" dirty="0"/>
+          </a:p>
+        </p:txBody>
+      </p:sp>
+      <p:sp>
+        <p:nvSpPr>
+          <p:cNvPr id="16" name="Text 14">
+            <a:extLst>
+              <a:ext uri="{FF2B5EF4-FFF2-40B4-BE49-F238E27FC236}">
+                <a16:creationId xmlns:a16="http://schemas.microsoft.com/office/drawing/2014/main" id="{6E12C554-0BD7-4C5A-64B4-99AD6D2AB2EC}"/>
+              </a:ext>
+            </a:extLst>
+          </p:cNvPr>
+          <p:cNvSpPr/>
+          <p:nvPr/>
+        </p:nvSpPr>
+        <p:spPr>
+          <a:xfrm>
+            <a:off x="2102983" y="7276510"/>
+            <a:ext cx="768046" cy="768046"/>
+          </a:xfrm>
+          <a:prstGeom prst="ellipse">
+            <a:avLst/>
+          </a:prstGeom>
+          <a:solidFill>
+            <a:srgbClr val="087D7D"/>
+          </a:solidFill>
+          <a:ln>
+            <a:solidFill>
+              <a:srgbClr val="087D7D"/>
+            </a:solidFill>
+          </a:ln>
+        </p:spPr>
+        <p:txBody>
+          <a:bodyPr wrap="square" lIns="0" tIns="0" rIns="0" bIns="0" rtlCol="0" anchor="ctr"/>
+          <a:lstStyle/>
+          <a:p>
+            <a:pPr algn="ctr"/>
+            <a:r>
+              <a:rPr lang="en-US" sz="3000" b="1" noProof="0" dirty="0">
+                <a:solidFill>
+                  <a:srgbClr val="FFFFFF"/>
+                </a:solidFill>
+              </a:rPr>
+              <a:t>4</a:t>
+            </a:r>
+            <a:endParaRPr lang="en-US" sz="3000" noProof="0" dirty="0"/>
+          </a:p>
+        </p:txBody>
+      </p:sp>
+      <p:sp>
+        <p:nvSpPr>
+          <p:cNvPr id="17" name="Text 15">
+            <a:extLst>
+              <a:ext uri="{FF2B5EF4-FFF2-40B4-BE49-F238E27FC236}">
+                <a16:creationId xmlns:a16="http://schemas.microsoft.com/office/drawing/2014/main" id="{E2049D28-0925-66E9-1991-6A7D7C8E9473}"/>
+              </a:ext>
+            </a:extLst>
+          </p:cNvPr>
+          <p:cNvSpPr/>
+          <p:nvPr/>
+        </p:nvSpPr>
+        <p:spPr>
+          <a:xfrm>
+            <a:off x="3328199" y="7367956"/>
+            <a:ext cx="14829172" cy="498597"/>
+          </a:xfrm>
+          <a:prstGeom prst="rect">
+            <a:avLst/>
+          </a:prstGeom>
+          <a:noFill/>
+          <a:ln/>
+        </p:spPr>
+        <p:txBody>
+          <a:bodyPr wrap="square" lIns="0" tIns="0" rIns="0" bIns="0" rtlCol="0" anchor="ctr"/>
+          <a:lstStyle/>
+          <a:p>
+            <a:r>
+              <a:rPr lang="en-US" sz="3400" b="1" noProof="0" dirty="0">
+                <a:solidFill>
+                  <a:srgbClr val="172C3A"/>
+                </a:solidFill>
+              </a:rPr>
+              <a:t>In the browser address bar, insert </a:t>
+            </a:r>
+            <a:r>
+              <a:rPr lang="en-US" sz="3400" b="1" noProof="0" dirty="0" err="1">
+                <a:solidFill>
+                  <a:srgbClr val="172C3A"/>
+                </a:solidFill>
+              </a:rPr>
+              <a:t>tocolab</a:t>
+            </a:r>
+            <a:r>
+              <a:rPr lang="en-US" sz="3400" b="1" noProof="0" dirty="0">
+                <a:solidFill>
+                  <a:srgbClr val="172C3A"/>
+                </a:solidFill>
+              </a:rPr>
+              <a:t> after </a:t>
+            </a:r>
+            <a:r>
+              <a:rPr lang="en-US" sz="3400" b="1" noProof="0" dirty="0" err="1">
+                <a:solidFill>
+                  <a:srgbClr val="172C3A"/>
+                </a:solidFill>
+              </a:rPr>
+              <a:t>github</a:t>
+            </a:r>
+            <a:endParaRPr lang="en-US" sz="3400" noProof="0" dirty="0"/>
+          </a:p>
+        </p:txBody>
+      </p:sp>
+      <p:sp>
+        <p:nvSpPr>
+          <p:cNvPr id="19" name="Shape 17">
+            <a:extLst>
+              <a:ext uri="{FF2B5EF4-FFF2-40B4-BE49-F238E27FC236}">
+                <a16:creationId xmlns:a16="http://schemas.microsoft.com/office/drawing/2014/main" id="{E1718BF9-A98A-CB71-50D1-2C020D9ED440}"/>
+              </a:ext>
+            </a:extLst>
+          </p:cNvPr>
+          <p:cNvSpPr/>
+          <p:nvPr/>
+        </p:nvSpPr>
+        <p:spPr>
+          <a:xfrm>
+            <a:off x="2487006" y="8135990"/>
+            <a:ext cx="0" cy="475457"/>
+          </a:xfrm>
+          <a:prstGeom prst="line">
+            <a:avLst/>
+          </a:prstGeom>
+          <a:noFill/>
+          <a:ln w="15240">
+            <a:solidFill>
+              <a:srgbClr val="D0D8DD"/>
+            </a:solidFill>
+            <a:prstDash val="solid"/>
+          </a:ln>
+        </p:spPr>
+        <p:txBody>
+          <a:bodyPr/>
+          <a:lstStyle/>
+          <a:p>
+            <a:endParaRPr lang="en-US" sz="3600" noProof="0" dirty="0"/>
+          </a:p>
+        </p:txBody>
+      </p:sp>
+      <p:sp>
+        <p:nvSpPr>
+          <p:cNvPr id="20" name="Text 18">
+            <a:extLst>
+              <a:ext uri="{FF2B5EF4-FFF2-40B4-BE49-F238E27FC236}">
+                <a16:creationId xmlns:a16="http://schemas.microsoft.com/office/drawing/2014/main" id="{EF3FF913-9371-A975-4BD9-FDE3C819E1D5}"/>
+              </a:ext>
+            </a:extLst>
+          </p:cNvPr>
+          <p:cNvSpPr/>
+          <p:nvPr/>
+        </p:nvSpPr>
+        <p:spPr>
+          <a:xfrm>
+            <a:off x="2102983" y="8702881"/>
+            <a:ext cx="768046" cy="768046"/>
+          </a:xfrm>
+          <a:prstGeom prst="ellipse">
+            <a:avLst/>
+          </a:prstGeom>
+          <a:solidFill>
+            <a:srgbClr val="087D7D"/>
+          </a:solidFill>
+          <a:ln>
+            <a:solidFill>
+              <a:srgbClr val="087D7D"/>
+            </a:solidFill>
+          </a:ln>
+        </p:spPr>
+        <p:txBody>
+          <a:bodyPr wrap="square" lIns="0" tIns="0" rIns="0" bIns="0" rtlCol="0" anchor="ctr"/>
+          <a:lstStyle/>
+          <a:p>
+            <a:pPr algn="ctr"/>
+            <a:r>
+              <a:rPr lang="en-US" sz="3000" b="1" noProof="0" dirty="0">
+                <a:solidFill>
+                  <a:srgbClr val="FFFFFF"/>
+                </a:solidFill>
+              </a:rPr>
+              <a:t>5</a:t>
+            </a:r>
+            <a:endParaRPr lang="en-US" sz="3000" noProof="0" dirty="0"/>
+          </a:p>
+        </p:txBody>
+      </p:sp>
+      <p:sp>
+        <p:nvSpPr>
+          <p:cNvPr id="21" name="Text 19">
+            <a:extLst>
+              <a:ext uri="{FF2B5EF4-FFF2-40B4-BE49-F238E27FC236}">
+                <a16:creationId xmlns:a16="http://schemas.microsoft.com/office/drawing/2014/main" id="{D87260E0-E187-AC97-9416-B123141678B0}"/>
+              </a:ext>
+            </a:extLst>
+          </p:cNvPr>
+          <p:cNvSpPr/>
+          <p:nvPr/>
+        </p:nvSpPr>
+        <p:spPr>
+          <a:xfrm>
+            <a:off x="3328199" y="8794327"/>
+            <a:ext cx="14829172" cy="498597"/>
+          </a:xfrm>
+          <a:prstGeom prst="rect">
+            <a:avLst/>
+          </a:prstGeom>
+          <a:noFill/>
+          <a:ln/>
+        </p:spPr>
+        <p:txBody>
+          <a:bodyPr wrap="square" lIns="0" tIns="0" rIns="0" bIns="0" rtlCol="0" anchor="ctr"/>
+          <a:lstStyle/>
+          <a:p>
+            <a:r>
+              <a:rPr lang="en-US" sz="3400" b="1" noProof="0" dirty="0">
+                <a:solidFill>
+                  <a:srgbClr val="172C3A"/>
+                </a:solidFill>
+              </a:rPr>
+              <a:t>The URL should start with githubtocolab.com</a:t>
+            </a:r>
+            <a:endParaRPr lang="en-US" sz="3400" noProof="0" dirty="0"/>
+          </a:p>
+        </p:txBody>
+      </p:sp>
+      <p:sp>
+        <p:nvSpPr>
+          <p:cNvPr id="23" name="Shape 21">
+            <a:extLst>
+              <a:ext uri="{FF2B5EF4-FFF2-40B4-BE49-F238E27FC236}">
+                <a16:creationId xmlns:a16="http://schemas.microsoft.com/office/drawing/2014/main" id="{2D81EB7B-9B26-5622-57E6-3B1D3C019774}"/>
+              </a:ext>
+            </a:extLst>
+          </p:cNvPr>
+          <p:cNvSpPr/>
+          <p:nvPr/>
+        </p:nvSpPr>
+        <p:spPr>
+          <a:xfrm>
+            <a:off x="2487006" y="9562361"/>
+            <a:ext cx="0" cy="475457"/>
+          </a:xfrm>
+          <a:prstGeom prst="line">
+            <a:avLst/>
+          </a:prstGeom>
+          <a:noFill/>
+          <a:ln w="15240">
+            <a:solidFill>
+              <a:srgbClr val="D0D8DD"/>
+            </a:solidFill>
+            <a:prstDash val="solid"/>
+          </a:ln>
+        </p:spPr>
+        <p:txBody>
+          <a:bodyPr/>
+          <a:lstStyle/>
+          <a:p>
+            <a:endParaRPr lang="en-US" sz="3600" noProof="0" dirty="0"/>
+          </a:p>
+        </p:txBody>
+      </p:sp>
+      <p:sp>
+        <p:nvSpPr>
+          <p:cNvPr id="24" name="Text 22">
+            <a:extLst>
+              <a:ext uri="{FF2B5EF4-FFF2-40B4-BE49-F238E27FC236}">
+                <a16:creationId xmlns:a16="http://schemas.microsoft.com/office/drawing/2014/main" id="{43C95936-E951-FC51-0A6C-5F9EAC786781}"/>
+              </a:ext>
+            </a:extLst>
+          </p:cNvPr>
+          <p:cNvSpPr/>
+          <p:nvPr/>
+        </p:nvSpPr>
+        <p:spPr>
+          <a:xfrm>
+            <a:off x="2102983" y="10129252"/>
+            <a:ext cx="768046" cy="768046"/>
+          </a:xfrm>
+          <a:prstGeom prst="ellipse">
+            <a:avLst/>
+          </a:prstGeom>
+          <a:solidFill>
+            <a:srgbClr val="087D7D"/>
+          </a:solidFill>
+          <a:ln>
+            <a:solidFill>
+              <a:srgbClr val="087D7D"/>
+            </a:solidFill>
+          </a:ln>
+        </p:spPr>
+        <p:txBody>
+          <a:bodyPr wrap="square" lIns="0" tIns="0" rIns="0" bIns="0" rtlCol="0" anchor="ctr"/>
+          <a:lstStyle/>
+          <a:p>
+            <a:pPr algn="ctr"/>
+            <a:r>
+              <a:rPr lang="en-US" sz="3000" b="1" noProof="0" dirty="0">
+                <a:solidFill>
+                  <a:srgbClr val="FFFFFF"/>
+                </a:solidFill>
+              </a:rPr>
+              <a:t>6</a:t>
+            </a:r>
+            <a:endParaRPr lang="en-US" sz="3000" noProof="0" dirty="0"/>
+          </a:p>
+        </p:txBody>
+      </p:sp>
+      <p:sp>
+        <p:nvSpPr>
+          <p:cNvPr id="25" name="Text 23">
+            <a:extLst>
+              <a:ext uri="{FF2B5EF4-FFF2-40B4-BE49-F238E27FC236}">
+                <a16:creationId xmlns:a16="http://schemas.microsoft.com/office/drawing/2014/main" id="{2BFC472E-916A-F56A-3434-8E3899B879B8}"/>
+              </a:ext>
+            </a:extLst>
+          </p:cNvPr>
+          <p:cNvSpPr/>
+          <p:nvPr/>
+        </p:nvSpPr>
+        <p:spPr>
+          <a:xfrm>
+            <a:off x="3328199" y="10220698"/>
+            <a:ext cx="14829172" cy="498597"/>
+          </a:xfrm>
+          <a:prstGeom prst="rect">
+            <a:avLst/>
+          </a:prstGeom>
+          <a:noFill/>
+          <a:ln/>
+        </p:spPr>
+        <p:txBody>
+          <a:bodyPr wrap="square" lIns="0" tIns="0" rIns="0" bIns="0" rtlCol="0" anchor="ctr"/>
+          <a:lstStyle/>
+          <a:p>
+            <a:r>
+              <a:rPr lang="en-US" sz="3400" b="1" noProof="0" dirty="0">
+                <a:solidFill>
+                  <a:srgbClr val="172C3A"/>
+                </a:solidFill>
+              </a:rPr>
+              <a:t>Press Enter to open the notebook in Google </a:t>
+            </a:r>
+            <a:r>
+              <a:rPr lang="en-US" sz="3400" b="1" noProof="0" dirty="0" err="1">
+                <a:solidFill>
+                  <a:srgbClr val="172C3A"/>
+                </a:solidFill>
+              </a:rPr>
+              <a:t>Colab</a:t>
+            </a:r>
+            <a:endParaRPr lang="en-US" sz="3400" noProof="0" dirty="0"/>
+          </a:p>
+        </p:txBody>
+      </p:sp>
+      <p:sp>
+        <p:nvSpPr>
+          <p:cNvPr id="31" name="Text 29">
+            <a:extLst>
+              <a:ext uri="{FF2B5EF4-FFF2-40B4-BE49-F238E27FC236}">
+                <a16:creationId xmlns:a16="http://schemas.microsoft.com/office/drawing/2014/main" id="{B3EE5A98-96B0-8449-5B94-26DE0F114BCE}"/>
+              </a:ext>
+            </a:extLst>
+          </p:cNvPr>
+          <p:cNvSpPr/>
+          <p:nvPr/>
+        </p:nvSpPr>
+        <p:spPr>
+          <a:xfrm>
+            <a:off x="23132814" y="12892647"/>
+            <a:ext cx="640038" cy="329163"/>
+          </a:xfrm>
+          <a:prstGeom prst="rect">
+            <a:avLst/>
+          </a:prstGeom>
+          <a:noFill/>
+          <a:ln/>
+        </p:spPr>
+        <p:txBody>
+          <a:bodyPr wrap="square" lIns="0" tIns="0" rIns="0" bIns="0" rtlCol="0" anchor="ctr"/>
+          <a:lstStyle/>
+          <a:p>
+            <a:pPr algn="r"/>
+            <a:r>
+              <a:rPr lang="en-US" sz="1700" noProof="0" dirty="0">
+                <a:solidFill>
+                  <a:srgbClr val="607280"/>
+                </a:solidFill>
+              </a:rPr>
+              <a:t>7</a:t>
+            </a:r>
+            <a:endParaRPr lang="en-US" sz="1700" noProof="0" dirty="0"/>
+          </a:p>
+        </p:txBody>
+      </p:sp>
+      <p:sp>
+        <p:nvSpPr>
+          <p:cNvPr id="32" name="TextBox 2">
+            <a:extLst>
+              <a:ext uri="{FF2B5EF4-FFF2-40B4-BE49-F238E27FC236}">
+                <a16:creationId xmlns:a16="http://schemas.microsoft.com/office/drawing/2014/main" id="{D052367D-6466-3C75-FC51-4A8F0071C12F}"/>
+              </a:ext>
+            </a:extLst>
+          </p:cNvPr>
+          <p:cNvSpPr txBox="1"/>
+          <p:nvPr/>
+        </p:nvSpPr>
+        <p:spPr>
+          <a:xfrm>
+            <a:off x="1060634" y="1737695"/>
+            <a:ext cx="5452895" cy="498596"/>
+          </a:xfrm>
+          <a:prstGeom prst="rect">
+            <a:avLst/>
+          </a:prstGeom>
+          <a:noFill/>
+        </p:spPr>
+        <p:txBody>
+          <a:bodyPr wrap="none" lIns="54860" tIns="18287" rIns="54860" bIns="18287">
+            <a:spAutoFit/>
+          </a:bodyPr>
+          <a:lstStyle/>
+          <a:p>
+            <a:pPr>
+              <a:defRPr sz="1500" b="0">
+                <a:solidFill>
+                  <a:srgbClr val="5B697D"/>
+                </a:solidFill>
+                <a:latin typeface="Aptos"/>
+              </a:defRPr>
+            </a:pPr>
+            <a:r>
+              <a:rPr lang="en-US" sz="3000" noProof="0" dirty="0"/>
+              <a:t>Uploaded to </a:t>
+            </a:r>
+            <a:r>
+              <a:rPr lang="en-US" sz="3000" noProof="0" dirty="0" err="1"/>
+              <a:t>github</a:t>
+            </a:r>
+            <a:r>
+              <a:rPr lang="en-US" sz="3000" noProof="0" dirty="0"/>
+              <a:t>, use in </a:t>
+            </a:r>
+            <a:r>
+              <a:rPr lang="en-US" sz="3000" noProof="0" dirty="0" err="1"/>
+              <a:t>colab</a:t>
+            </a:r>
+            <a:endParaRPr lang="en-US" sz="3000" noProof="0" dirty="0"/>
+          </a:p>
+        </p:txBody>
+      </p:sp>
+      <p:sp>
+        <p:nvSpPr>
+          <p:cNvPr id="33" name="Élőláb helye 3">
+            <a:extLst>
+              <a:ext uri="{FF2B5EF4-FFF2-40B4-BE49-F238E27FC236}">
+                <a16:creationId xmlns:a16="http://schemas.microsoft.com/office/drawing/2014/main" id="{0240ADD3-4ADC-7F38-50F0-3684334581AA}"/>
+              </a:ext>
+            </a:extLst>
+          </p:cNvPr>
+          <p:cNvSpPr txBox="1">
+            <a:spLocks/>
+          </p:cNvSpPr>
+          <p:nvPr/>
+        </p:nvSpPr>
+        <p:spPr>
+          <a:xfrm>
+            <a:off x="1153220" y="12574479"/>
+            <a:ext cx="9957167" cy="730250"/>
+          </a:xfrm>
+          <a:prstGeom prst="rect">
+            <a:avLst/>
+          </a:prstGeom>
+        </p:spPr>
+        <p:txBody>
+          <a:bodyPr anchor="ctr"/>
+          <a:lstStyle>
+            <a:defPPr>
+              <a:defRPr lang="en-US"/>
+            </a:defPPr>
+            <a:lvl1pPr marL="0" algn="l" defTabSz="457200" rtl="0" eaLnBrk="1" latinLnBrk="0" hangingPunct="1">
+              <a:defRPr sz="1800" kern="1200">
+                <a:solidFill>
+                  <a:schemeClr val="tx1"/>
+                </a:solidFill>
+                <a:latin typeface="+mn-lt"/>
+                <a:ea typeface="+mn-ea"/>
+                <a:cs typeface="+mn-cs"/>
+              </a:defRPr>
+            </a:lvl1pPr>
+            <a:lvl2pPr marL="457200" algn="l" defTabSz="457200" rtl="0" eaLnBrk="1" latinLnBrk="0" hangingPunct="1">
+              <a:defRPr sz="1800" kern="1200">
+                <a:solidFill>
+                  <a:schemeClr val="tx1"/>
+                </a:solidFill>
+                <a:latin typeface="+mn-lt"/>
+                <a:ea typeface="+mn-ea"/>
+                <a:cs typeface="+mn-cs"/>
+              </a:defRPr>
+            </a:lvl2pPr>
+            <a:lvl3pPr marL="914400" algn="l" defTabSz="457200" rtl="0" eaLnBrk="1" latinLnBrk="0" hangingPunct="1">
+              <a:defRPr sz="1800" kern="1200">
+                <a:solidFill>
+                  <a:schemeClr val="tx1"/>
+                </a:solidFill>
+                <a:latin typeface="+mn-lt"/>
+                <a:ea typeface="+mn-ea"/>
+                <a:cs typeface="+mn-cs"/>
+              </a:defRPr>
+            </a:lvl3pPr>
+            <a:lvl4pPr marL="1371600" algn="l" defTabSz="457200" rtl="0" eaLnBrk="1" latinLnBrk="0" hangingPunct="1">
+              <a:defRPr sz="1800" kern="1200">
+                <a:solidFill>
+                  <a:schemeClr val="tx1"/>
+                </a:solidFill>
+                <a:latin typeface="+mn-lt"/>
+                <a:ea typeface="+mn-ea"/>
+                <a:cs typeface="+mn-cs"/>
+              </a:defRPr>
+            </a:lvl4pPr>
+            <a:lvl5pPr marL="1828800" algn="l" defTabSz="457200" rtl="0" eaLnBrk="1" latinLnBrk="0" hangingPunct="1">
+              <a:defRPr sz="1800" kern="1200">
+                <a:solidFill>
+                  <a:schemeClr val="tx1"/>
+                </a:solidFill>
+                <a:latin typeface="+mn-lt"/>
+                <a:ea typeface="+mn-ea"/>
+                <a:cs typeface="+mn-cs"/>
+              </a:defRPr>
+            </a:lvl5pPr>
+            <a:lvl6pPr marL="2286000" algn="l" defTabSz="457200" rtl="0" eaLnBrk="1" latinLnBrk="0" hangingPunct="1">
+              <a:defRPr sz="1800" kern="1200">
+                <a:solidFill>
+                  <a:schemeClr val="tx1"/>
+                </a:solidFill>
+                <a:latin typeface="+mn-lt"/>
+                <a:ea typeface="+mn-ea"/>
+                <a:cs typeface="+mn-cs"/>
+              </a:defRPr>
+            </a:lvl6pPr>
+            <a:lvl7pPr marL="2743200" algn="l" defTabSz="457200" rtl="0" eaLnBrk="1" latinLnBrk="0" hangingPunct="1">
+              <a:defRPr sz="1800" kern="1200">
+                <a:solidFill>
+                  <a:schemeClr val="tx1"/>
+                </a:solidFill>
+                <a:latin typeface="+mn-lt"/>
+                <a:ea typeface="+mn-ea"/>
+                <a:cs typeface="+mn-cs"/>
+              </a:defRPr>
+            </a:lvl7pPr>
+            <a:lvl8pPr marL="3200400" algn="l" defTabSz="457200" rtl="0" eaLnBrk="1" latinLnBrk="0" hangingPunct="1">
+              <a:defRPr sz="1800" kern="1200">
+                <a:solidFill>
+                  <a:schemeClr val="tx1"/>
+                </a:solidFill>
+                <a:latin typeface="+mn-lt"/>
+                <a:ea typeface="+mn-ea"/>
+                <a:cs typeface="+mn-cs"/>
+              </a:defRPr>
+            </a:lvl8pPr>
+            <a:lvl9pPr marL="3657600" algn="l" defTabSz="457200" rtl="0" eaLnBrk="1" latinLnBrk="0" hangingPunct="1">
+              <a:defRPr sz="1800" kern="1200">
+                <a:solidFill>
+                  <a:schemeClr val="tx1"/>
+                </a:solidFill>
+                <a:latin typeface="+mn-lt"/>
+                <a:ea typeface="+mn-ea"/>
+                <a:cs typeface="+mn-cs"/>
+              </a:defRPr>
+            </a:lvl9pPr>
+          </a:lstStyle>
+          <a:p>
+            <a:r>
+              <a:rPr lang="en-US" sz="3200" noProof="0" dirty="0">
+                <a:solidFill>
+                  <a:schemeClr val="bg1"/>
+                </a:solidFill>
+              </a:rPr>
               <a:t>Understanding BERT for Medical Text Classification</a:t>
             </a:r>
-            <a:endParaRPr lang="hu-HU" sz="3200" dirty="0"/>
           </a:p>
         </p:txBody>
       </p:sp>
     </p:spTree>
     <p:extLst>
       <p:ext uri="{BB962C8B-B14F-4D97-AF65-F5344CB8AC3E}">
-        <p14:creationId xmlns:p14="http://schemas.microsoft.com/office/powerpoint/2010/main" val="1148136087"/>
+        <p14:creationId xmlns:p14="http://schemas.microsoft.com/office/powerpoint/2010/main" val="108500753"/>
       </p:ext>
     </p:extLst>
   </p:cSld>
@@ -14313,6 +17019,15 @@
 </file>
 
 <file path=customXml/item2.xml><?xml version="1.0" encoding="utf-8"?>
+<?mso-contentType ?>
+<FormTemplates xmlns="http://schemas.microsoft.com/sharepoint/v3/contenttype/forms">
+  <Display>DocumentLibraryForm</Display>
+  <Edit>DocumentLibraryForm</Edit>
+  <New>DocumentLibraryForm</New>
+</FormTemplates>
+</file>
+
+<file path=customXml/item3.xml><?xml version="1.0" encoding="utf-8"?>
 <ct:contentTypeSchema xmlns:ct="http://schemas.microsoft.com/office/2006/metadata/contentType" xmlns:ma="http://schemas.microsoft.com/office/2006/metadata/properties/metaAttributes" ct:_="" ma:_="" ma:contentTypeName="Document" ma:contentTypeID="0x0101000DC9086D2F38074EB30FEE325F126BDC" ma:contentTypeVersion="13" ma:contentTypeDescription="Create a new document." ma:contentTypeScope="" ma:versionID="f6f81e6001d427b3c6d71046c610852c">
   <xsd:schema xmlns:xsd="http://www.w3.org/2001/XMLSchema" xmlns:xs="http://www.w3.org/2001/XMLSchema" xmlns:p="http://schemas.microsoft.com/office/2006/metadata/properties" xmlns:ns2="b95b538e-9dbf-4a6a-adce-c060378dfeb3" xmlns:ns3="b7e8f6af-84b5-48c1-8f1b-6d4a6a50693b" targetNamespace="http://schemas.microsoft.com/office/2006/metadata/properties" ma:root="true" ma:fieldsID="6e80591dae5f7dcb6fbdf0af7c789373" ns2:_="" ns3:_="">
     <xsd:import namespace="b95b538e-9dbf-4a6a-adce-c060378dfeb3"/>
@@ -14519,15 +17234,6 @@
 </ct:contentTypeSchema>
 </file>
 
-<file path=customXml/item3.xml><?xml version="1.0" encoding="utf-8"?>
-<?mso-contentType ?>
-<FormTemplates xmlns="http://schemas.microsoft.com/sharepoint/v3/contenttype/forms">
-  <Display>DocumentLibraryForm</Display>
-  <Edit>DocumentLibraryForm</Edit>
-  <New>DocumentLibraryForm</New>
-</FormTemplates>
-</file>
-
 <file path=customXml/itemProps1.xml><?xml version="1.0" encoding="utf-8"?>
 <ds:datastoreItem xmlns:ds="http://schemas.openxmlformats.org/officeDocument/2006/customXml" ds:itemID="{1AF4F2AF-AACE-40E5-8A5C-C4314E0850E6}">
   <ds:schemaRefs>
@@ -14548,6 +17254,14 @@
 </file>
 
 <file path=customXml/itemProps2.xml><?xml version="1.0" encoding="utf-8"?>
+<ds:datastoreItem xmlns:ds="http://schemas.openxmlformats.org/officeDocument/2006/customXml" ds:itemID="{2B3D62FE-57A0-46B6-9049-24ABBB08E7B1}">
+  <ds:schemaRefs>
+    <ds:schemaRef ds:uri="http://schemas.microsoft.com/sharepoint/v3/contenttype/forms"/>
+  </ds:schemaRefs>
+</ds:datastoreItem>
+</file>
+
+<file path=customXml/itemProps3.xml><?xml version="1.0" encoding="utf-8"?>
 <ds:datastoreItem xmlns:ds="http://schemas.openxmlformats.org/officeDocument/2006/customXml" ds:itemID="{0A0B6866-5A64-4A63-A643-40A643302FE0}">
   <ds:schemaRefs>
     <ds:schemaRef ds:uri="http://schemas.microsoft.com/office/2006/metadata/contentType"/>
@@ -14564,12 +17278,4 @@
     <ds:schemaRef ds:uri="http://schemas.microsoft.com/internal/obd"/>
   </ds:schemaRefs>
 </ds:datastoreItem>
-</file>
-
-<file path=customXml/itemProps3.xml><?xml version="1.0" encoding="utf-8"?>
-<ds:datastoreItem xmlns:ds="http://schemas.openxmlformats.org/officeDocument/2006/customXml" ds:itemID="{2B3D62FE-57A0-46B6-9049-24ABBB08E7B1}">
-  <ds:schemaRefs>
-    <ds:schemaRef ds:uri="http://schemas.microsoft.com/sharepoint/v3/contenttype/forms"/>
-  </ds:schemaRefs>
-</ds:datastoreItem>
 </file>
</xml_diff>